<commit_message>
docs: API call section in viva Q&A; light title slide, footer text removed, separate thank-you slide
</commit_message>
<xml_diff>
--- a/presentation/Sarabo_Presentation.pptx
+++ b/presentation/Sarabo_Presentation.pptx
@@ -15,6 +15,7 @@
     <p:sldId id="263" r:id="rId15"/>
     <p:sldId id="264" r:id="rId16"/>
     <p:sldId id="265" r:id="rId17"/>
+    <p:sldId id="266" r:id="rId18"/>
   </p:sldIdLst>
   <p:sldSz cx="12191695" cy="6858000" type="screen4x3"/>
   <p:notesSz cx="6858000" cy="9144000"/>
@@ -581,7 +582,77 @@
           <a:lstStyle/>
           <a:p>
             <a:r>
-              <a:t>[4:35-5:00] All server tests and all 58 browser tests pass, and the system is live; all twelve objectives were met. Limits: Stripe is in test mode, payouts are manual, and there are no real users yet. Next: a local payment gateway and a mobile app. Thank you, now the live demo.</a:t>
+              <a:t>[4:35-4:55] All server tests and all 58 browser tests pass, and the system is live; all twelve objectives were met. Limits: Stripe is in test mode, payouts are manual, and there are no real users yet. Next: a local payment gateway and a mobile app.</a:t>
+            </a:r>
+          </a:p>
+        </p:txBody>
+      </p:sp>
+      <p:sp>
+        <p:nvSpPr>
+          <p:cNvPr id="4" name="Slide Number Placeholder 3"/>
+          <p:cNvSpPr>
+            <a:spLocks noGrp="1"/>
+          </p:cNvSpPr>
+          <p:nvPr>
+            <p:ph type="sldNum" idx="5" sz="quarter"/>
+          </p:nvPr>
+        </p:nvSpPr>
+        <p:spPr/>
+      </p:sp>
+    </p:spTree>
+  </p:cSld>
+  <p:clrMapOvr>
+    <a:masterClrMapping/>
+  </p:clrMapOvr>
+</p:notes>
+</file>
+
+<file path=ppt/notesSlides/notesSlide11.xml><?xml version="1.0" encoding="utf-8"?>
+<p:notes xmlns:a="http://schemas.openxmlformats.org/drawingml/2006/main" xmlns:p="http://schemas.openxmlformats.org/presentationml/2006/main" xmlns:r="http://schemas.openxmlformats.org/officeDocument/2006/relationships">
+  <p:cSld>
+    <p:spTree>
+      <p:nvGrpSpPr>
+        <p:cNvPr id="1" name=""/>
+        <p:cNvGrpSpPr/>
+        <p:nvPr/>
+      </p:nvGrpSpPr>
+      <p:grpSpPr>
+        <a:xfrm>
+          <a:off x="0" y="0"/>
+          <a:ext cx="0" cy="0"/>
+          <a:chOff x="0" y="0"/>
+          <a:chExt cx="0" cy="0"/>
+        </a:xfrm>
+      </p:grpSpPr>
+      <p:sp>
+        <p:nvSpPr>
+          <p:cNvPr id="2" name="Slide Image Placeholder 1"/>
+          <p:cNvSpPr>
+            <a:spLocks noGrp="1"/>
+          </p:cNvSpPr>
+          <p:nvPr>
+            <p:ph type="sldImg" idx="2"/>
+          </p:nvPr>
+        </p:nvSpPr>
+        <p:spPr/>
+      </p:sp>
+      <p:sp>
+        <p:nvSpPr>
+          <p:cNvPr id="3" name="Notes Placeholder 2"/>
+          <p:cNvSpPr>
+            <a:spLocks noGrp="1"/>
+          </p:cNvSpPr>
+          <p:nvPr>
+            <p:ph type="body" idx="3" sz="quarter"/>
+          </p:nvPr>
+        </p:nvSpPr>
+        <p:spPr/>
+        <p:txBody>
+          <a:bodyPr/>
+          <a:lstStyle/>
+          <a:p>
+            <a:r>
+              <a:t>[4:55-5:00] Thank you. Now let me show you Rahim's repair, live.</a:t>
             </a:r>
           </a:p>
         </p:txBody>
@@ -4143,7 +4214,7 @@
     <p:bg>
       <p:bgPr>
         <a:solidFill>
-          <a:srgbClr val="0F2430"/>
+          <a:srgbClr val="F6F7F5"/>
         </a:solidFill>
         <a:effectLst/>
       </p:bgPr>
@@ -4201,7 +4272,7 @@
       </p:sp>
       <p:pic>
         <p:nvPicPr>
-          <p:cNvPr id="3" name="Picture 2" descr="logo-on-ink.png"/>
+          <p:cNvPr id="3" name="Picture 2" descr="logo.png"/>
           <p:cNvPicPr>
             <a:picLocks noChangeAspect="1"/>
           </p:cNvPicPr>
@@ -4253,7 +4324,7 @@
             <a:r>
               <a:rPr sz="4400" b="1">
                 <a:solidFill>
-                  <a:srgbClr val="FFFFFF"/>
+                  <a:srgbClr val="0F2430"/>
                 </a:solidFill>
                 <a:latin typeface="Segoe UI"/>
               </a:rPr>
@@ -4292,7 +4363,7 @@
             <a:r>
               <a:rPr sz="2600" b="0">
                 <a:solidFill>
-                  <a:srgbClr val="F2B138"/>
+                  <a:srgbClr val="1E6F63"/>
                 </a:solidFill>
                 <a:latin typeface="Segoe UI"/>
               </a:rPr>
@@ -4331,7 +4402,7 @@
             <a:r>
               <a:rPr sz="2600" b="1">
                 <a:solidFill>
-                  <a:srgbClr val="FFFFFF"/>
+                  <a:srgbClr val="0F2430"/>
                 </a:solidFill>
                 <a:latin typeface="Segoe UI"/>
               </a:rPr>
@@ -4347,7 +4418,7 @@
             <a:r>
               <a:rPr sz="2000" b="0">
                 <a:solidFill>
-                  <a:srgbClr val="C9D4D8"/>
+                  <a:srgbClr val="45555D"/>
                 </a:solidFill>
                 <a:latin typeface="Segoe UI"/>
               </a:rPr>
@@ -4363,7 +4434,7 @@
             <a:r>
               <a:rPr sz="2000" b="0">
                 <a:solidFill>
-                  <a:srgbClr val="C9D4D8"/>
+                  <a:srgbClr val="45555D"/>
                 </a:solidFill>
                 <a:latin typeface="Segoe UI"/>
               </a:rPr>
@@ -4379,7 +4450,7 @@
             <a:r>
               <a:rPr sz="2000" b="0">
                 <a:solidFill>
-                  <a:srgbClr val="C9D4D8"/>
+                  <a:srgbClr val="45555D"/>
                 </a:solidFill>
                 <a:latin typeface="Segoe UI"/>
               </a:rPr>
@@ -4407,8 +4478,10 @@
           <a:solidFill>
             <a:srgbClr val="FFFFFF"/>
           </a:solidFill>
-          <a:ln>
-            <a:noFill/>
+          <a:ln w="15875">
+            <a:solidFill>
+              <a:srgbClr val="C9CFCB"/>
+            </a:solidFill>
           </a:ln>
           <a:effectLst/>
         </p:spPr>
@@ -4570,45 +4643,6 @@
         </p:nvSpPr>
         <p:spPr>
           <a:xfrm>
-            <a:off x="640080" y="6446520"/>
-            <a:ext cx="6400800" cy="274320"/>
-          </a:xfrm>
-          <a:prstGeom prst="rect">
-            <a:avLst/>
-          </a:prstGeom>
-          <a:noFill/>
-        </p:spPr>
-        <p:txBody>
-          <a:bodyPr wrap="square" lIns="0" rIns="0" tIns="0" bIns="0" anchor="t">
-            <a:spAutoFit/>
-          </a:bodyPr>
-          <a:lstStyle/>
-          <a:p>
-            <a:pPr algn="l">
-              <a:lnSpc>
-                <a:spcPct val="110000"/>
-              </a:lnSpc>
-            </a:pPr>
-            <a:r>
-              <a:rPr sz="1200" b="0">
-                <a:solidFill>
-                  <a:srgbClr val="45555D"/>
-                </a:solidFill>
-                <a:latin typeface="Segoe UI"/>
-              </a:rPr>
-              <a:t>Sarabo  ·  Jahid Hasan  ·  Metropolitan University</a:t>
-            </a:r>
-          </a:p>
-        </p:txBody>
-      </p:sp>
-      <p:sp>
-        <p:nvSpPr>
-          <p:cNvPr id="5" name="TextBox 4"/>
-          <p:cNvSpPr txBox="1"/>
-          <p:nvPr/>
-        </p:nvSpPr>
-        <p:spPr>
-          <a:xfrm>
             <a:off x="10634472" y="6446520"/>
             <a:ext cx="914400" cy="274320"/>
           </a:xfrm>
@@ -4635,14 +4669,14 @@
                 </a:solidFill>
                 <a:latin typeface="Segoe UI"/>
               </a:rPr>
-              <a:t>10/10</a:t>
-            </a:r>
-          </a:p>
-        </p:txBody>
-      </p:sp>
-      <p:sp>
-        <p:nvSpPr>
-          <p:cNvPr id="6" name="Rounded Rectangle 5"/>
+              <a:t>10/11</a:t>
+            </a:r>
+          </a:p>
+        </p:txBody>
+      </p:sp>
+      <p:sp>
+        <p:nvSpPr>
+          <p:cNvPr id="5" name="Rounded Rectangle 4"/>
           <p:cNvSpPr/>
           <p:nvPr/>
         </p:nvSpPr>
@@ -4690,7 +4724,7 @@
       </p:sp>
       <p:sp>
         <p:nvSpPr>
-          <p:cNvPr id="7" name="TextBox 6"/>
+          <p:cNvPr id="6" name="TextBox 5"/>
           <p:cNvSpPr txBox="1"/>
           <p:nvPr/>
         </p:nvSpPr>
@@ -4729,7 +4763,7 @@
       </p:sp>
       <p:sp>
         <p:nvSpPr>
-          <p:cNvPr id="8" name="TextBox 7"/>
+          <p:cNvPr id="7" name="TextBox 6"/>
           <p:cNvSpPr txBox="1"/>
           <p:nvPr/>
         </p:nvSpPr>
@@ -4768,7 +4802,7 @@
       </p:sp>
       <p:sp>
         <p:nvSpPr>
-          <p:cNvPr id="9" name="Rounded Rectangle 8"/>
+          <p:cNvPr id="8" name="Rounded Rectangle 7"/>
           <p:cNvSpPr/>
           <p:nvPr/>
         </p:nvSpPr>
@@ -4816,7 +4850,7 @@
       </p:sp>
       <p:sp>
         <p:nvSpPr>
-          <p:cNvPr id="10" name="TextBox 9"/>
+          <p:cNvPr id="9" name="TextBox 8"/>
           <p:cNvSpPr txBox="1"/>
           <p:nvPr/>
         </p:nvSpPr>
@@ -4855,7 +4889,7 @@
       </p:sp>
       <p:sp>
         <p:nvSpPr>
-          <p:cNvPr id="11" name="TextBox 10"/>
+          <p:cNvPr id="10" name="TextBox 9"/>
           <p:cNvSpPr txBox="1"/>
           <p:nvPr/>
         </p:nvSpPr>
@@ -4894,7 +4928,7 @@
       </p:sp>
       <p:sp>
         <p:nvSpPr>
-          <p:cNvPr id="12" name="Rounded Rectangle 11"/>
+          <p:cNvPr id="11" name="Rounded Rectangle 10"/>
           <p:cNvSpPr/>
           <p:nvPr/>
         </p:nvSpPr>
@@ -4942,7 +4976,7 @@
       </p:sp>
       <p:sp>
         <p:nvSpPr>
-          <p:cNvPr id="13" name="TextBox 12"/>
+          <p:cNvPr id="12" name="TextBox 11"/>
           <p:cNvSpPr txBox="1"/>
           <p:nvPr/>
         </p:nvSpPr>
@@ -4981,7 +5015,7 @@
       </p:sp>
       <p:sp>
         <p:nvSpPr>
-          <p:cNvPr id="14" name="TextBox 13"/>
+          <p:cNvPr id="13" name="TextBox 12"/>
           <p:cNvSpPr txBox="1"/>
           <p:nvPr/>
         </p:nvSpPr>
@@ -5020,7 +5054,7 @@
       </p:sp>
       <p:sp>
         <p:nvSpPr>
-          <p:cNvPr id="15" name="Rounded Rectangle 14"/>
+          <p:cNvPr id="14" name="Rounded Rectangle 13"/>
           <p:cNvSpPr/>
           <p:nvPr/>
         </p:nvSpPr>
@@ -5068,7 +5102,7 @@
       </p:sp>
       <p:sp>
         <p:nvSpPr>
-          <p:cNvPr id="16" name="TextBox 15"/>
+          <p:cNvPr id="15" name="TextBox 14"/>
           <p:cNvSpPr txBox="1"/>
           <p:nvPr/>
         </p:nvSpPr>
@@ -5107,7 +5141,7 @@
       </p:sp>
       <p:sp>
         <p:nvSpPr>
-          <p:cNvPr id="17" name="TextBox 16"/>
+          <p:cNvPr id="16" name="TextBox 15"/>
           <p:cNvSpPr txBox="1"/>
           <p:nvPr/>
         </p:nvSpPr>
@@ -5146,7 +5180,7 @@
       </p:sp>
       <p:sp>
         <p:nvSpPr>
-          <p:cNvPr id="18" name="TextBox 17"/>
+          <p:cNvPr id="17" name="TextBox 16"/>
           <p:cNvSpPr txBox="1"/>
           <p:nvPr/>
         </p:nvSpPr>
@@ -5185,7 +5219,7 @@
       </p:sp>
       <p:sp>
         <p:nvSpPr>
-          <p:cNvPr id="19" name="TextBox 18"/>
+          <p:cNvPr id="18" name="TextBox 17"/>
           <p:cNvSpPr txBox="1"/>
           <p:nvPr/>
         </p:nvSpPr>
@@ -5258,7 +5292,7 @@
       </p:sp>
       <p:sp>
         <p:nvSpPr>
-          <p:cNvPr id="20" name="TextBox 19"/>
+          <p:cNvPr id="19" name="TextBox 18"/>
           <p:cNvSpPr txBox="1"/>
           <p:nvPr/>
         </p:nvSpPr>
@@ -5297,7 +5331,7 @@
       </p:sp>
       <p:sp>
         <p:nvSpPr>
-          <p:cNvPr id="21" name="TextBox 20"/>
+          <p:cNvPr id="20" name="TextBox 19"/>
           <p:cNvSpPr txBox="1"/>
           <p:nvPr/>
         </p:nvSpPr>
@@ -5368,16 +5402,188 @@
           </a:p>
         </p:txBody>
       </p:sp>
-      <p:sp>
-        <p:nvSpPr>
-          <p:cNvPr id="22" name="Rounded Rectangle 21"/>
+    </p:spTree>
+  </p:cSld>
+  <p:clrMapOvr>
+    <a:masterClrMapping/>
+  </p:clrMapOvr>
+</p:sld>
+</file>
+
+<file path=ppt/slides/slide11.xml><?xml version="1.0" encoding="utf-8"?>
+<p:sld xmlns:a="http://schemas.openxmlformats.org/drawingml/2006/main" xmlns:p="http://schemas.openxmlformats.org/presentationml/2006/main" xmlns:r="http://schemas.openxmlformats.org/officeDocument/2006/relationships">
+  <p:cSld>
+    <p:bg>
+      <p:bgPr>
+        <a:solidFill>
+          <a:srgbClr val="F6F7F5"/>
+        </a:solidFill>
+        <a:effectLst/>
+      </p:bgPr>
+    </p:bg>
+    <p:spTree>
+      <p:nvGrpSpPr>
+        <p:cNvPr id="1" name=""/>
+        <p:cNvGrpSpPr/>
+        <p:nvPr/>
+      </p:nvGrpSpPr>
+      <p:grpSpPr/>
+      <p:sp>
+        <p:nvSpPr>
+          <p:cNvPr id="2" name="Rectangle 1"/>
           <p:cNvSpPr/>
           <p:nvPr/>
         </p:nvSpPr>
         <p:spPr>
           <a:xfrm>
-            <a:off x="640080" y="5440680"/>
-            <a:ext cx="10908792" cy="731520"/>
+            <a:off x="0" y="0"/>
+            <a:ext cx="201168" cy="6858000"/>
+          </a:xfrm>
+          <a:prstGeom prst="rect">
+            <a:avLst/>
+          </a:prstGeom>
+          <a:solidFill>
+            <a:srgbClr val="F2B138"/>
+          </a:solidFill>
+          <a:ln>
+            <a:noFill/>
+          </a:ln>
+          <a:effectLst/>
+        </p:spPr>
+        <p:style>
+          <a:lnRef idx="1">
+            <a:schemeClr val="accent1"/>
+          </a:lnRef>
+          <a:fillRef idx="3">
+            <a:schemeClr val="accent1"/>
+          </a:fillRef>
+          <a:effectRef idx="2">
+            <a:schemeClr val="accent1"/>
+          </a:effectRef>
+          <a:fontRef idx="minor">
+            <a:schemeClr val="lt1"/>
+          </a:fontRef>
+        </p:style>
+        <p:txBody>
+          <a:bodyPr rtlCol="0" anchor="ctr"/>
+          <a:lstStyle/>
+          <a:p>
+            <a:pPr algn="ctr"/>
+          </a:p>
+        </p:txBody>
+      </p:sp>
+      <p:pic>
+        <p:nvPicPr>
+          <p:cNvPr id="3" name="Picture 2" descr="logo.png"/>
+          <p:cNvPicPr>
+            <a:picLocks noChangeAspect="1"/>
+          </p:cNvPicPr>
+          <p:nvPr/>
+        </p:nvPicPr>
+        <p:blipFill>
+          <a:blip r:embed="rId2"/>
+          <a:stretch>
+            <a:fillRect/>
+          </a:stretch>
+        </p:blipFill>
+        <p:spPr>
+          <a:xfrm>
+            <a:off x="822960" y="731520"/>
+            <a:ext cx="2057400" cy="822960"/>
+          </a:xfrm>
+          <a:prstGeom prst="rect">
+            <a:avLst/>
+          </a:prstGeom>
+        </p:spPr>
+      </p:pic>
+      <p:sp>
+        <p:nvSpPr>
+          <p:cNvPr id="4" name="TextBox 3"/>
+          <p:cNvSpPr txBox="1"/>
+          <p:nvPr/>
+        </p:nvSpPr>
+        <p:spPr>
+          <a:xfrm>
+            <a:off x="822960" y="2103120"/>
+            <a:ext cx="10515600" cy="1188720"/>
+          </a:xfrm>
+          <a:prstGeom prst="rect">
+            <a:avLst/>
+          </a:prstGeom>
+          <a:noFill/>
+        </p:spPr>
+        <p:txBody>
+          <a:bodyPr wrap="square" lIns="0" rIns="0" tIns="0" bIns="0" anchor="t">
+            <a:spAutoFit/>
+          </a:bodyPr>
+          <a:lstStyle/>
+          <a:p>
+            <a:pPr algn="l">
+              <a:lnSpc>
+                <a:spcPct val="110000"/>
+              </a:lnSpc>
+            </a:pPr>
+            <a:r>
+              <a:rPr sz="6600" b="1">
+                <a:solidFill>
+                  <a:srgbClr val="0F2430"/>
+                </a:solidFill>
+                <a:latin typeface="Segoe UI"/>
+              </a:rPr>
+              <a:t>Thank you.</a:t>
+            </a:r>
+          </a:p>
+        </p:txBody>
+      </p:sp>
+      <p:sp>
+        <p:nvSpPr>
+          <p:cNvPr id="5" name="TextBox 4"/>
+          <p:cNvSpPr txBox="1"/>
+          <p:nvPr/>
+        </p:nvSpPr>
+        <p:spPr>
+          <a:xfrm>
+            <a:off x="822960" y="3429000"/>
+            <a:ext cx="10515600" cy="548640"/>
+          </a:xfrm>
+          <a:prstGeom prst="rect">
+            <a:avLst/>
+          </a:prstGeom>
+          <a:noFill/>
+        </p:spPr>
+        <p:txBody>
+          <a:bodyPr wrap="square" lIns="0" rIns="0" tIns="0" bIns="0" anchor="t">
+            <a:spAutoFit/>
+          </a:bodyPr>
+          <a:lstStyle/>
+          <a:p>
+            <a:pPr algn="l">
+              <a:lnSpc>
+                <a:spcPct val="110000"/>
+              </a:lnSpc>
+            </a:pPr>
+            <a:r>
+              <a:rPr sz="3000" b="1">
+                <a:solidFill>
+                  <a:srgbClr val="1E6F63"/>
+                </a:solidFill>
+                <a:latin typeface="Segoe UI"/>
+              </a:rPr>
+              <a:t>Now, the live demo</a:t>
+            </a:r>
+          </a:p>
+        </p:txBody>
+      </p:sp>
+      <p:sp>
+        <p:nvSpPr>
+          <p:cNvPr id="6" name="Rounded Rectangle 5"/>
+          <p:cNvSpPr/>
+          <p:nvPr/>
+        </p:nvSpPr>
+        <p:spPr>
+          <a:xfrm>
+            <a:off x="822960" y="4343400"/>
+            <a:ext cx="6949440" cy="868680"/>
           </a:xfrm>
           <a:prstGeom prst="roundRect">
             <a:avLst>
@@ -5416,14 +5622,14 @@
       </p:sp>
       <p:sp>
         <p:nvSpPr>
-          <p:cNvPr id="23" name="TextBox 22"/>
+          <p:cNvPr id="7" name="TextBox 6"/>
           <p:cNvSpPr txBox="1"/>
           <p:nvPr/>
         </p:nvSpPr>
         <p:spPr>
           <a:xfrm>
-            <a:off x="960120" y="5440680"/>
-            <a:ext cx="10268712" cy="731520"/>
+            <a:off x="1143000" y="4343400"/>
+            <a:ext cx="6400800" cy="868680"/>
           </a:xfrm>
           <a:prstGeom prst="rect">
             <a:avLst/>
@@ -5442,22 +5648,133 @@
               </a:lnSpc>
             </a:pPr>
             <a:r>
-              <a:rPr sz="2200" b="1">
+              <a:rPr sz="2400" b="1">
+                <a:solidFill>
+                  <a:srgbClr val="F2B138"/>
+                </a:solidFill>
+                <a:latin typeface="Segoe UI"/>
+              </a:rPr>
+              <a:t>Live  </a:t>
+            </a:r>
+            <a:r>
+              <a:rPr sz="2400" b="0">
                 <a:solidFill>
                   <a:srgbClr val="FFFFFF"/>
                 </a:solidFill>
                 <a:latin typeface="Segoe UI"/>
               </a:rPr>
-              <a:t>Thank you.  </a:t>
-            </a:r>
-            <a:r>
-              <a:rPr sz="2200" b="0">
-                <a:solidFill>
-                  <a:srgbClr val="F2B138"/>
-                </a:solidFill>
-                <a:latin typeface="Segoe UI"/>
-              </a:rPr>
-              <a:t>Live demo next  ·  sarabo-client-six.vercel.app</a:t>
+              <a:t>sarabo-client-six.vercel.app</a:t>
+            </a:r>
+          </a:p>
+        </p:txBody>
+      </p:sp>
+      <p:sp>
+        <p:nvSpPr>
+          <p:cNvPr id="8" name="Rounded Rectangle 7"/>
+          <p:cNvSpPr/>
+          <p:nvPr/>
+        </p:nvSpPr>
+        <p:spPr>
+          <a:xfrm>
+            <a:off x="8625535" y="4709160"/>
+            <a:ext cx="2834640" cy="1463040"/>
+          </a:xfrm>
+          <a:prstGeom prst="roundRect">
+            <a:avLst>
+              <a:gd name="adj" fmla="val 6000"/>
+            </a:avLst>
+          </a:prstGeom>
+          <a:solidFill>
+            <a:srgbClr val="FFFFFF"/>
+          </a:solidFill>
+          <a:ln w="15875">
+            <a:solidFill>
+              <a:srgbClr val="C9CFCB"/>
+            </a:solidFill>
+          </a:ln>
+          <a:effectLst/>
+        </p:spPr>
+        <p:style>
+          <a:lnRef idx="1">
+            <a:schemeClr val="accent1"/>
+          </a:lnRef>
+          <a:fillRef idx="3">
+            <a:schemeClr val="accent1"/>
+          </a:fillRef>
+          <a:effectRef idx="2">
+            <a:schemeClr val="accent1"/>
+          </a:effectRef>
+          <a:fontRef idx="minor">
+            <a:schemeClr val="lt1"/>
+          </a:fontRef>
+        </p:style>
+        <p:txBody>
+          <a:bodyPr rtlCol="0" anchor="ctr"/>
+          <a:lstStyle/>
+          <a:p>
+            <a:pPr algn="ctr"/>
+          </a:p>
+        </p:txBody>
+      </p:sp>
+      <p:pic>
+        <p:nvPicPr>
+          <p:cNvPr id="9" name="Picture 8" descr="metrologo.png"/>
+          <p:cNvPicPr>
+            <a:picLocks noChangeAspect="1"/>
+          </p:cNvPicPr>
+          <p:nvPr/>
+        </p:nvPicPr>
+        <p:blipFill>
+          <a:blip r:embed="rId3"/>
+          <a:stretch>
+            <a:fillRect/>
+          </a:stretch>
+        </p:blipFill>
+        <p:spPr>
+          <a:xfrm>
+            <a:off x="8762695" y="4800600"/>
+            <a:ext cx="2560320" cy="1266092"/>
+          </a:xfrm>
+          <a:prstGeom prst="rect">
+            <a:avLst/>
+          </a:prstGeom>
+        </p:spPr>
+      </p:pic>
+      <p:sp>
+        <p:nvSpPr>
+          <p:cNvPr id="10" name="TextBox 9"/>
+          <p:cNvSpPr txBox="1"/>
+          <p:nvPr/>
+        </p:nvSpPr>
+        <p:spPr>
+          <a:xfrm>
+            <a:off x="10634472" y="6446520"/>
+            <a:ext cx="914400" cy="274320"/>
+          </a:xfrm>
+          <a:prstGeom prst="rect">
+            <a:avLst/>
+          </a:prstGeom>
+          <a:noFill/>
+        </p:spPr>
+        <p:txBody>
+          <a:bodyPr wrap="square" lIns="0" rIns="0" tIns="0" bIns="0" anchor="t">
+            <a:spAutoFit/>
+          </a:bodyPr>
+          <a:lstStyle/>
+          <a:p>
+            <a:pPr algn="r">
+              <a:lnSpc>
+                <a:spcPct val="110000"/>
+              </a:lnSpc>
+            </a:pPr>
+            <a:r>
+              <a:rPr sz="1200" b="0">
+                <a:solidFill>
+                  <a:srgbClr val="45555D"/>
+                </a:solidFill>
+                <a:latin typeface="Segoe UI"/>
+              </a:rPr>
+              <a:t>11/11</a:t>
             </a:r>
           </a:p>
         </p:txBody>
@@ -5574,45 +5891,6 @@
         </p:nvSpPr>
         <p:spPr>
           <a:xfrm>
-            <a:off x="640080" y="6446520"/>
-            <a:ext cx="6400800" cy="274320"/>
-          </a:xfrm>
-          <a:prstGeom prst="rect">
-            <a:avLst/>
-          </a:prstGeom>
-          <a:noFill/>
-        </p:spPr>
-        <p:txBody>
-          <a:bodyPr wrap="square" lIns="0" rIns="0" tIns="0" bIns="0" anchor="t">
-            <a:spAutoFit/>
-          </a:bodyPr>
-          <a:lstStyle/>
-          <a:p>
-            <a:pPr algn="l">
-              <a:lnSpc>
-                <a:spcPct val="110000"/>
-              </a:lnSpc>
-            </a:pPr>
-            <a:r>
-              <a:rPr sz="1200" b="0">
-                <a:solidFill>
-                  <a:srgbClr val="45555D"/>
-                </a:solidFill>
-                <a:latin typeface="Segoe UI"/>
-              </a:rPr>
-              <a:t>Sarabo  ·  Jahid Hasan  ·  Metropolitan University</a:t>
-            </a:r>
-          </a:p>
-        </p:txBody>
-      </p:sp>
-      <p:sp>
-        <p:nvSpPr>
-          <p:cNvPr id="5" name="TextBox 4"/>
-          <p:cNvSpPr txBox="1"/>
-          <p:nvPr/>
-        </p:nvSpPr>
-        <p:spPr>
-          <a:xfrm>
             <a:off x="10634472" y="6446520"/>
             <a:ext cx="914400" cy="274320"/>
           </a:xfrm>
@@ -5639,14 +5917,14 @@
                 </a:solidFill>
                 <a:latin typeface="Segoe UI"/>
               </a:rPr>
-              <a:t>2/10</a:t>
-            </a:r>
-          </a:p>
-        </p:txBody>
-      </p:sp>
-      <p:sp>
-        <p:nvSpPr>
-          <p:cNvPr id="6" name="Rounded Rectangle 5"/>
+              <a:t>2/11</a:t>
+            </a:r>
+          </a:p>
+        </p:txBody>
+      </p:sp>
+      <p:sp>
+        <p:nvSpPr>
+          <p:cNvPr id="5" name="Rounded Rectangle 4"/>
           <p:cNvSpPr/>
           <p:nvPr/>
         </p:nvSpPr>
@@ -5694,7 +5972,7 @@
       </p:sp>
       <p:sp>
         <p:nvSpPr>
-          <p:cNvPr id="7" name="Rectangle 6"/>
+          <p:cNvPr id="6" name="Rectangle 5"/>
           <p:cNvSpPr/>
           <p:nvPr/>
         </p:nvSpPr>
@@ -5738,7 +6016,7 @@
       </p:sp>
       <p:sp>
         <p:nvSpPr>
-          <p:cNvPr id="8" name="TextBox 7"/>
+          <p:cNvPr id="7" name="TextBox 6"/>
           <p:cNvSpPr txBox="1"/>
           <p:nvPr/>
         </p:nvSpPr>
@@ -5777,7 +6055,7 @@
       </p:sp>
       <p:sp>
         <p:nvSpPr>
-          <p:cNvPr id="9" name="TextBox 8"/>
+          <p:cNvPr id="8" name="TextBox 7"/>
           <p:cNvSpPr txBox="1"/>
           <p:nvPr/>
         </p:nvSpPr>
@@ -5850,7 +6128,7 @@
       </p:sp>
       <p:sp>
         <p:nvSpPr>
-          <p:cNvPr id="10" name="Rounded Rectangle 9"/>
+          <p:cNvPr id="9" name="Rounded Rectangle 8"/>
           <p:cNvSpPr/>
           <p:nvPr/>
         </p:nvSpPr>
@@ -5898,7 +6176,7 @@
       </p:sp>
       <p:sp>
         <p:nvSpPr>
-          <p:cNvPr id="11" name="Rectangle 10"/>
+          <p:cNvPr id="10" name="Rectangle 9"/>
           <p:cNvSpPr/>
           <p:nvPr/>
         </p:nvSpPr>
@@ -5942,7 +6220,7 @@
       </p:sp>
       <p:sp>
         <p:nvSpPr>
-          <p:cNvPr id="12" name="TextBox 11"/>
+          <p:cNvPr id="11" name="TextBox 10"/>
           <p:cNvSpPr txBox="1"/>
           <p:nvPr/>
         </p:nvSpPr>
@@ -5981,7 +6259,7 @@
       </p:sp>
       <p:sp>
         <p:nvSpPr>
-          <p:cNvPr id="13" name="TextBox 12"/>
+          <p:cNvPr id="12" name="TextBox 11"/>
           <p:cNvSpPr txBox="1"/>
           <p:nvPr/>
         </p:nvSpPr>
@@ -6054,7 +6332,7 @@
       </p:sp>
       <p:sp>
         <p:nvSpPr>
-          <p:cNvPr id="14" name="Rounded Rectangle 13"/>
+          <p:cNvPr id="13" name="Rounded Rectangle 12"/>
           <p:cNvSpPr/>
           <p:nvPr/>
         </p:nvSpPr>
@@ -6102,7 +6380,7 @@
       </p:sp>
       <p:sp>
         <p:nvSpPr>
-          <p:cNvPr id="15" name="Rectangle 14"/>
+          <p:cNvPr id="14" name="Rectangle 13"/>
           <p:cNvSpPr/>
           <p:nvPr/>
         </p:nvSpPr>
@@ -6146,7 +6424,7 @@
       </p:sp>
       <p:sp>
         <p:nvSpPr>
-          <p:cNvPr id="16" name="TextBox 15"/>
+          <p:cNvPr id="15" name="TextBox 14"/>
           <p:cNvSpPr txBox="1"/>
           <p:nvPr/>
         </p:nvSpPr>
@@ -6185,7 +6463,7 @@
       </p:sp>
       <p:sp>
         <p:nvSpPr>
-          <p:cNvPr id="17" name="TextBox 16"/>
+          <p:cNvPr id="16" name="TextBox 15"/>
           <p:cNvSpPr txBox="1"/>
           <p:nvPr/>
         </p:nvSpPr>
@@ -6258,7 +6536,7 @@
       </p:sp>
       <p:sp>
         <p:nvSpPr>
-          <p:cNvPr id="18" name="Rounded Rectangle 17"/>
+          <p:cNvPr id="17" name="Rounded Rectangle 16"/>
           <p:cNvSpPr/>
           <p:nvPr/>
         </p:nvSpPr>
@@ -6304,7 +6582,7 @@
       </p:sp>
       <p:sp>
         <p:nvSpPr>
-          <p:cNvPr id="19" name="TextBox 18"/>
+          <p:cNvPr id="18" name="TextBox 17"/>
           <p:cNvSpPr txBox="1"/>
           <p:nvPr/>
         </p:nvSpPr>
@@ -6453,45 +6731,6 @@
         </p:nvSpPr>
         <p:spPr>
           <a:xfrm>
-            <a:off x="640080" y="6446520"/>
-            <a:ext cx="6400800" cy="274320"/>
-          </a:xfrm>
-          <a:prstGeom prst="rect">
-            <a:avLst/>
-          </a:prstGeom>
-          <a:noFill/>
-        </p:spPr>
-        <p:txBody>
-          <a:bodyPr wrap="square" lIns="0" rIns="0" tIns="0" bIns="0" anchor="t">
-            <a:spAutoFit/>
-          </a:bodyPr>
-          <a:lstStyle/>
-          <a:p>
-            <a:pPr algn="l">
-              <a:lnSpc>
-                <a:spcPct val="110000"/>
-              </a:lnSpc>
-            </a:pPr>
-            <a:r>
-              <a:rPr sz="1200" b="0">
-                <a:solidFill>
-                  <a:srgbClr val="45555D"/>
-                </a:solidFill>
-                <a:latin typeface="Segoe UI"/>
-              </a:rPr>
-              <a:t>Sarabo  ·  Jahid Hasan  ·  Metropolitan University</a:t>
-            </a:r>
-          </a:p>
-        </p:txBody>
-      </p:sp>
-      <p:sp>
-        <p:nvSpPr>
-          <p:cNvPr id="5" name="TextBox 4"/>
-          <p:cNvSpPr txBox="1"/>
-          <p:nvPr/>
-        </p:nvSpPr>
-        <p:spPr>
-          <a:xfrm>
             <a:off x="10634472" y="6446520"/>
             <a:ext cx="914400" cy="274320"/>
           </a:xfrm>
@@ -6518,14 +6757,14 @@
                 </a:solidFill>
                 <a:latin typeface="Segoe UI"/>
               </a:rPr>
-              <a:t>3/10</a:t>
-            </a:r>
-          </a:p>
-        </p:txBody>
-      </p:sp>
-      <p:sp>
-        <p:nvSpPr>
-          <p:cNvPr id="6" name="Rounded Rectangle 5"/>
+              <a:t>3/11</a:t>
+            </a:r>
+          </a:p>
+        </p:txBody>
+      </p:sp>
+      <p:sp>
+        <p:nvSpPr>
+          <p:cNvPr id="5" name="Rounded Rectangle 4"/>
           <p:cNvSpPr/>
           <p:nvPr/>
         </p:nvSpPr>
@@ -6573,7 +6812,7 @@
       </p:sp>
       <p:sp>
         <p:nvSpPr>
-          <p:cNvPr id="7" name="Rectangle 6"/>
+          <p:cNvPr id="6" name="Rectangle 5"/>
           <p:cNvSpPr/>
           <p:nvPr/>
         </p:nvSpPr>
@@ -6617,7 +6856,7 @@
       </p:sp>
       <p:sp>
         <p:nvSpPr>
-          <p:cNvPr id="8" name="TextBox 7"/>
+          <p:cNvPr id="7" name="TextBox 6"/>
           <p:cNvSpPr txBox="1"/>
           <p:nvPr/>
         </p:nvSpPr>
@@ -6656,7 +6895,7 @@
       </p:sp>
       <p:sp>
         <p:nvSpPr>
-          <p:cNvPr id="9" name="TextBox 8"/>
+          <p:cNvPr id="8" name="TextBox 7"/>
           <p:cNvSpPr txBox="1"/>
           <p:nvPr/>
         </p:nvSpPr>
@@ -6695,7 +6934,7 @@
       </p:sp>
       <p:sp>
         <p:nvSpPr>
-          <p:cNvPr id="10" name="Rounded Rectangle 9"/>
+          <p:cNvPr id="9" name="Rounded Rectangle 8"/>
           <p:cNvSpPr/>
           <p:nvPr/>
         </p:nvSpPr>
@@ -6743,7 +6982,7 @@
       </p:sp>
       <p:sp>
         <p:nvSpPr>
-          <p:cNvPr id="11" name="Rectangle 10"/>
+          <p:cNvPr id="10" name="Rectangle 9"/>
           <p:cNvSpPr/>
           <p:nvPr/>
         </p:nvSpPr>
@@ -6787,7 +7026,7 @@
       </p:sp>
       <p:sp>
         <p:nvSpPr>
-          <p:cNvPr id="12" name="TextBox 11"/>
+          <p:cNvPr id="11" name="TextBox 10"/>
           <p:cNvSpPr txBox="1"/>
           <p:nvPr/>
         </p:nvSpPr>
@@ -6826,7 +7065,7 @@
       </p:sp>
       <p:sp>
         <p:nvSpPr>
-          <p:cNvPr id="13" name="TextBox 12"/>
+          <p:cNvPr id="12" name="TextBox 11"/>
           <p:cNvSpPr txBox="1"/>
           <p:nvPr/>
         </p:nvSpPr>
@@ -6865,7 +7104,7 @@
       </p:sp>
       <p:sp>
         <p:nvSpPr>
-          <p:cNvPr id="14" name="Rounded Rectangle 13"/>
+          <p:cNvPr id="13" name="Rounded Rectangle 12"/>
           <p:cNvSpPr/>
           <p:nvPr/>
         </p:nvSpPr>
@@ -6913,7 +7152,7 @@
       </p:sp>
       <p:sp>
         <p:nvSpPr>
-          <p:cNvPr id="15" name="Rectangle 14"/>
+          <p:cNvPr id="14" name="Rectangle 13"/>
           <p:cNvSpPr/>
           <p:nvPr/>
         </p:nvSpPr>
@@ -6957,7 +7196,7 @@
       </p:sp>
       <p:sp>
         <p:nvSpPr>
-          <p:cNvPr id="16" name="TextBox 15"/>
+          <p:cNvPr id="15" name="TextBox 14"/>
           <p:cNvSpPr txBox="1"/>
           <p:nvPr/>
         </p:nvSpPr>
@@ -6996,7 +7235,7 @@
       </p:sp>
       <p:sp>
         <p:nvSpPr>
-          <p:cNvPr id="17" name="TextBox 16"/>
+          <p:cNvPr id="16" name="TextBox 15"/>
           <p:cNvSpPr txBox="1"/>
           <p:nvPr/>
         </p:nvSpPr>
@@ -7035,7 +7274,7 @@
       </p:sp>
       <p:pic>
         <p:nvPicPr>
-          <p:cNvPr id="18" name="Picture 17" descr="home.png"/>
+          <p:cNvPr id="17" name="Picture 16" descr="home.png"/>
           <p:cNvPicPr>
             <a:picLocks noChangeAspect="1"/>
           </p:cNvPicPr>
@@ -7064,7 +7303,7 @@
       </p:pic>
       <p:sp>
         <p:nvSpPr>
-          <p:cNvPr id="19" name="TextBox 18"/>
+          <p:cNvPr id="18" name="TextBox 17"/>
           <p:cNvSpPr txBox="1"/>
           <p:nvPr/>
         </p:nvSpPr>
@@ -7258,45 +7497,6 @@
         </p:nvSpPr>
         <p:spPr>
           <a:xfrm>
-            <a:off x="640080" y="6446520"/>
-            <a:ext cx="6400800" cy="274320"/>
-          </a:xfrm>
-          <a:prstGeom prst="rect">
-            <a:avLst/>
-          </a:prstGeom>
-          <a:noFill/>
-        </p:spPr>
-        <p:txBody>
-          <a:bodyPr wrap="square" lIns="0" rIns="0" tIns="0" bIns="0" anchor="t">
-            <a:spAutoFit/>
-          </a:bodyPr>
-          <a:lstStyle/>
-          <a:p>
-            <a:pPr algn="l">
-              <a:lnSpc>
-                <a:spcPct val="110000"/>
-              </a:lnSpc>
-            </a:pPr>
-            <a:r>
-              <a:rPr sz="1200" b="0">
-                <a:solidFill>
-                  <a:srgbClr val="45555D"/>
-                </a:solidFill>
-                <a:latin typeface="Segoe UI"/>
-              </a:rPr>
-              <a:t>Sarabo  ·  Jahid Hasan  ·  Metropolitan University</a:t>
-            </a:r>
-          </a:p>
-        </p:txBody>
-      </p:sp>
-      <p:sp>
-        <p:nvSpPr>
-          <p:cNvPr id="5" name="TextBox 4"/>
-          <p:cNvSpPr txBox="1"/>
-          <p:nvPr/>
-        </p:nvSpPr>
-        <p:spPr>
-          <a:xfrm>
             <a:off x="10634472" y="6446520"/>
             <a:ext cx="914400" cy="274320"/>
           </a:xfrm>
@@ -7323,14 +7523,14 @@
                 </a:solidFill>
                 <a:latin typeface="Segoe UI"/>
               </a:rPr>
-              <a:t>4/10</a:t>
-            </a:r>
-          </a:p>
-        </p:txBody>
-      </p:sp>
-      <p:sp>
-        <p:nvSpPr>
-          <p:cNvPr id="6" name="Rounded Rectangle 5"/>
+              <a:t>4/11</a:t>
+            </a:r>
+          </a:p>
+        </p:txBody>
+      </p:sp>
+      <p:sp>
+        <p:nvSpPr>
+          <p:cNvPr id="5" name="Rounded Rectangle 4"/>
           <p:cNvSpPr/>
           <p:nvPr/>
         </p:nvSpPr>
@@ -7378,7 +7578,7 @@
       </p:sp>
       <p:sp>
         <p:nvSpPr>
-          <p:cNvPr id="7" name="Oval 6"/>
+          <p:cNvPr id="6" name="Oval 5"/>
           <p:cNvSpPr/>
           <p:nvPr/>
         </p:nvSpPr>
@@ -7422,7 +7622,7 @@
       </p:sp>
       <p:sp>
         <p:nvSpPr>
-          <p:cNvPr id="8" name="TextBox 7"/>
+          <p:cNvPr id="7" name="TextBox 6"/>
           <p:cNvSpPr txBox="1"/>
           <p:nvPr/>
         </p:nvSpPr>
@@ -7461,7 +7661,7 @@
       </p:sp>
       <p:sp>
         <p:nvSpPr>
-          <p:cNvPr id="9" name="TextBox 8"/>
+          <p:cNvPr id="8" name="TextBox 7"/>
           <p:cNvSpPr txBox="1"/>
           <p:nvPr/>
         </p:nvSpPr>
@@ -7500,7 +7700,7 @@
       </p:sp>
       <p:sp>
         <p:nvSpPr>
-          <p:cNvPr id="10" name="TextBox 9"/>
+          <p:cNvPr id="9" name="TextBox 8"/>
           <p:cNvSpPr txBox="1"/>
           <p:nvPr/>
         </p:nvSpPr>
@@ -7539,7 +7739,7 @@
       </p:sp>
       <p:sp>
         <p:nvSpPr>
-          <p:cNvPr id="11" name="Rounded Rectangle 10"/>
+          <p:cNvPr id="10" name="Rounded Rectangle 9"/>
           <p:cNvSpPr/>
           <p:nvPr/>
         </p:nvSpPr>
@@ -7587,7 +7787,7 @@
       </p:sp>
       <p:sp>
         <p:nvSpPr>
-          <p:cNvPr id="12" name="Oval 11"/>
+          <p:cNvPr id="11" name="Oval 10"/>
           <p:cNvSpPr/>
           <p:nvPr/>
         </p:nvSpPr>
@@ -7631,7 +7831,7 @@
       </p:sp>
       <p:sp>
         <p:nvSpPr>
-          <p:cNvPr id="13" name="TextBox 12"/>
+          <p:cNvPr id="12" name="TextBox 11"/>
           <p:cNvSpPr txBox="1"/>
           <p:nvPr/>
         </p:nvSpPr>
@@ -7670,7 +7870,7 @@
       </p:sp>
       <p:sp>
         <p:nvSpPr>
-          <p:cNvPr id="14" name="TextBox 13"/>
+          <p:cNvPr id="13" name="TextBox 12"/>
           <p:cNvSpPr txBox="1"/>
           <p:nvPr/>
         </p:nvSpPr>
@@ -7709,7 +7909,7 @@
       </p:sp>
       <p:sp>
         <p:nvSpPr>
-          <p:cNvPr id="15" name="TextBox 14"/>
+          <p:cNvPr id="14" name="TextBox 13"/>
           <p:cNvSpPr txBox="1"/>
           <p:nvPr/>
         </p:nvSpPr>
@@ -7748,7 +7948,7 @@
       </p:sp>
       <p:sp>
         <p:nvSpPr>
-          <p:cNvPr id="16" name="Rounded Rectangle 15"/>
+          <p:cNvPr id="15" name="Rounded Rectangle 14"/>
           <p:cNvSpPr/>
           <p:nvPr/>
         </p:nvSpPr>
@@ -7796,7 +7996,7 @@
       </p:sp>
       <p:sp>
         <p:nvSpPr>
-          <p:cNvPr id="17" name="Oval 16"/>
+          <p:cNvPr id="16" name="Oval 15"/>
           <p:cNvSpPr/>
           <p:nvPr/>
         </p:nvSpPr>
@@ -7840,7 +8040,7 @@
       </p:sp>
       <p:sp>
         <p:nvSpPr>
-          <p:cNvPr id="18" name="TextBox 17"/>
+          <p:cNvPr id="17" name="TextBox 16"/>
           <p:cNvSpPr txBox="1"/>
           <p:nvPr/>
         </p:nvSpPr>
@@ -7879,7 +8079,7 @@
       </p:sp>
       <p:sp>
         <p:nvSpPr>
-          <p:cNvPr id="19" name="TextBox 18"/>
+          <p:cNvPr id="18" name="TextBox 17"/>
           <p:cNvSpPr txBox="1"/>
           <p:nvPr/>
         </p:nvSpPr>
@@ -7918,7 +8118,7 @@
       </p:sp>
       <p:sp>
         <p:nvSpPr>
-          <p:cNvPr id="20" name="TextBox 19"/>
+          <p:cNvPr id="19" name="TextBox 18"/>
           <p:cNvSpPr txBox="1"/>
           <p:nvPr/>
         </p:nvSpPr>
@@ -7957,7 +8157,7 @@
       </p:sp>
       <p:sp>
         <p:nvSpPr>
-          <p:cNvPr id="21" name="Rounded Rectangle 20"/>
+          <p:cNvPr id="20" name="Rounded Rectangle 19"/>
           <p:cNvSpPr/>
           <p:nvPr/>
         </p:nvSpPr>
@@ -8005,7 +8205,7 @@
       </p:sp>
       <p:sp>
         <p:nvSpPr>
-          <p:cNvPr id="22" name="Oval 21"/>
+          <p:cNvPr id="21" name="Oval 20"/>
           <p:cNvSpPr/>
           <p:nvPr/>
         </p:nvSpPr>
@@ -8049,7 +8249,7 @@
       </p:sp>
       <p:sp>
         <p:nvSpPr>
-          <p:cNvPr id="23" name="TextBox 22"/>
+          <p:cNvPr id="22" name="TextBox 21"/>
           <p:cNvSpPr txBox="1"/>
           <p:nvPr/>
         </p:nvSpPr>
@@ -8088,7 +8288,7 @@
       </p:sp>
       <p:sp>
         <p:nvSpPr>
-          <p:cNvPr id="24" name="TextBox 23"/>
+          <p:cNvPr id="23" name="TextBox 22"/>
           <p:cNvSpPr txBox="1"/>
           <p:nvPr/>
         </p:nvSpPr>
@@ -8127,7 +8327,7 @@
       </p:sp>
       <p:sp>
         <p:nvSpPr>
-          <p:cNvPr id="25" name="TextBox 24"/>
+          <p:cNvPr id="24" name="TextBox 23"/>
           <p:cNvSpPr txBox="1"/>
           <p:nvPr/>
         </p:nvSpPr>
@@ -8166,7 +8366,7 @@
       </p:sp>
       <p:sp>
         <p:nvSpPr>
-          <p:cNvPr id="26" name="Rounded Rectangle 25"/>
+          <p:cNvPr id="25" name="Rounded Rectangle 24"/>
           <p:cNvSpPr/>
           <p:nvPr/>
         </p:nvSpPr>
@@ -8214,7 +8414,7 @@
       </p:sp>
       <p:sp>
         <p:nvSpPr>
-          <p:cNvPr id="27" name="Oval 26"/>
+          <p:cNvPr id="26" name="Oval 25"/>
           <p:cNvSpPr/>
           <p:nvPr/>
         </p:nvSpPr>
@@ -8258,7 +8458,7 @@
       </p:sp>
       <p:sp>
         <p:nvSpPr>
-          <p:cNvPr id="28" name="TextBox 27"/>
+          <p:cNvPr id="27" name="TextBox 26"/>
           <p:cNvSpPr txBox="1"/>
           <p:nvPr/>
         </p:nvSpPr>
@@ -8297,7 +8497,7 @@
       </p:sp>
       <p:sp>
         <p:nvSpPr>
-          <p:cNvPr id="29" name="TextBox 28"/>
+          <p:cNvPr id="28" name="TextBox 27"/>
           <p:cNvSpPr txBox="1"/>
           <p:nvPr/>
         </p:nvSpPr>
@@ -8336,7 +8536,7 @@
       </p:sp>
       <p:sp>
         <p:nvSpPr>
-          <p:cNvPr id="30" name="TextBox 29"/>
+          <p:cNvPr id="29" name="TextBox 28"/>
           <p:cNvSpPr txBox="1"/>
           <p:nvPr/>
         </p:nvSpPr>
@@ -8375,7 +8575,7 @@
       </p:sp>
       <p:sp>
         <p:nvSpPr>
-          <p:cNvPr id="31" name="Rounded Rectangle 30"/>
+          <p:cNvPr id="30" name="Rounded Rectangle 29"/>
           <p:cNvSpPr/>
           <p:nvPr/>
         </p:nvSpPr>
@@ -8423,7 +8623,7 @@
       </p:sp>
       <p:sp>
         <p:nvSpPr>
-          <p:cNvPr id="32" name="Oval 31"/>
+          <p:cNvPr id="31" name="Oval 30"/>
           <p:cNvSpPr/>
           <p:nvPr/>
         </p:nvSpPr>
@@ -8467,7 +8667,7 @@
       </p:sp>
       <p:sp>
         <p:nvSpPr>
-          <p:cNvPr id="33" name="TextBox 32"/>
+          <p:cNvPr id="32" name="TextBox 31"/>
           <p:cNvSpPr txBox="1"/>
           <p:nvPr/>
         </p:nvSpPr>
@@ -8506,7 +8706,7 @@
       </p:sp>
       <p:sp>
         <p:nvSpPr>
-          <p:cNvPr id="34" name="TextBox 33"/>
+          <p:cNvPr id="33" name="TextBox 32"/>
           <p:cNvSpPr txBox="1"/>
           <p:nvPr/>
         </p:nvSpPr>
@@ -8545,7 +8745,7 @@
       </p:sp>
       <p:sp>
         <p:nvSpPr>
-          <p:cNvPr id="35" name="TextBox 34"/>
+          <p:cNvPr id="34" name="TextBox 33"/>
           <p:cNvSpPr txBox="1"/>
           <p:nvPr/>
         </p:nvSpPr>
@@ -8584,7 +8784,7 @@
       </p:sp>
       <p:sp>
         <p:nvSpPr>
-          <p:cNvPr id="36" name="Rounded Rectangle 35"/>
+          <p:cNvPr id="35" name="Rounded Rectangle 34"/>
           <p:cNvSpPr/>
           <p:nvPr/>
         </p:nvSpPr>
@@ -8630,7 +8830,7 @@
       </p:sp>
       <p:sp>
         <p:nvSpPr>
-          <p:cNvPr id="37" name="TextBox 36"/>
+          <p:cNvPr id="36" name="TextBox 35"/>
           <p:cNvSpPr txBox="1"/>
           <p:nvPr/>
         </p:nvSpPr>
@@ -8788,45 +8988,6 @@
         </p:nvSpPr>
         <p:spPr>
           <a:xfrm>
-            <a:off x="640080" y="6446520"/>
-            <a:ext cx="6400800" cy="274320"/>
-          </a:xfrm>
-          <a:prstGeom prst="rect">
-            <a:avLst/>
-          </a:prstGeom>
-          <a:noFill/>
-        </p:spPr>
-        <p:txBody>
-          <a:bodyPr wrap="square" lIns="0" rIns="0" tIns="0" bIns="0" anchor="t">
-            <a:spAutoFit/>
-          </a:bodyPr>
-          <a:lstStyle/>
-          <a:p>
-            <a:pPr algn="l">
-              <a:lnSpc>
-                <a:spcPct val="110000"/>
-              </a:lnSpc>
-            </a:pPr>
-            <a:r>
-              <a:rPr sz="1200" b="0">
-                <a:solidFill>
-                  <a:srgbClr val="45555D"/>
-                </a:solidFill>
-                <a:latin typeface="Segoe UI"/>
-              </a:rPr>
-              <a:t>Sarabo  ·  Jahid Hasan  ·  Metropolitan University</a:t>
-            </a:r>
-          </a:p>
-        </p:txBody>
-      </p:sp>
-      <p:sp>
-        <p:nvSpPr>
-          <p:cNvPr id="5" name="TextBox 4"/>
-          <p:cNvSpPr txBox="1"/>
-          <p:nvPr/>
-        </p:nvSpPr>
-        <p:spPr>
-          <a:xfrm>
             <a:off x="10634472" y="6446520"/>
             <a:ext cx="914400" cy="274320"/>
           </a:xfrm>
@@ -8853,14 +9014,14 @@
                 </a:solidFill>
                 <a:latin typeface="Segoe UI"/>
               </a:rPr>
-              <a:t>5/10</a:t>
-            </a:r>
-          </a:p>
-        </p:txBody>
-      </p:sp>
-      <p:sp>
-        <p:nvSpPr>
-          <p:cNvPr id="6" name="Rectangle 5"/>
+              <a:t>5/11</a:t>
+            </a:r>
+          </a:p>
+        </p:txBody>
+      </p:sp>
+      <p:sp>
+        <p:nvSpPr>
+          <p:cNvPr id="5" name="Rectangle 4"/>
           <p:cNvSpPr/>
           <p:nvPr/>
         </p:nvSpPr>
@@ -8906,7 +9067,7 @@
       </p:sp>
       <p:sp>
         <p:nvSpPr>
-          <p:cNvPr id="7" name="Rectangle 6"/>
+          <p:cNvPr id="6" name="Rectangle 5"/>
           <p:cNvSpPr/>
           <p:nvPr/>
         </p:nvSpPr>
@@ -8950,7 +9111,7 @@
       </p:sp>
       <p:sp>
         <p:nvSpPr>
-          <p:cNvPr id="8" name="TextBox 7"/>
+          <p:cNvPr id="7" name="TextBox 6"/>
           <p:cNvSpPr txBox="1"/>
           <p:nvPr/>
         </p:nvSpPr>
@@ -8989,7 +9150,7 @@
       </p:sp>
       <p:sp>
         <p:nvSpPr>
-          <p:cNvPr id="9" name="TextBox 8"/>
+          <p:cNvPr id="8" name="TextBox 7"/>
           <p:cNvSpPr txBox="1"/>
           <p:nvPr/>
         </p:nvSpPr>
@@ -9053,7 +9214,7 @@
       </p:sp>
       <p:sp>
         <p:nvSpPr>
-          <p:cNvPr id="10" name="Rectangle 9"/>
+          <p:cNvPr id="9" name="Rectangle 8"/>
           <p:cNvSpPr/>
           <p:nvPr/>
         </p:nvSpPr>
@@ -9099,7 +9260,7 @@
       </p:sp>
       <p:sp>
         <p:nvSpPr>
-          <p:cNvPr id="11" name="Rectangle 10"/>
+          <p:cNvPr id="10" name="Rectangle 9"/>
           <p:cNvSpPr/>
           <p:nvPr/>
         </p:nvSpPr>
@@ -9143,7 +9304,7 @@
       </p:sp>
       <p:sp>
         <p:nvSpPr>
-          <p:cNvPr id="12" name="TextBox 11"/>
+          <p:cNvPr id="11" name="TextBox 10"/>
           <p:cNvSpPr txBox="1"/>
           <p:nvPr/>
         </p:nvSpPr>
@@ -9182,7 +9343,7 @@
       </p:sp>
       <p:sp>
         <p:nvSpPr>
-          <p:cNvPr id="13" name="TextBox 12"/>
+          <p:cNvPr id="12" name="TextBox 11"/>
           <p:cNvSpPr txBox="1"/>
           <p:nvPr/>
         </p:nvSpPr>
@@ -9271,7 +9432,7 @@
       </p:sp>
       <p:sp>
         <p:nvSpPr>
-          <p:cNvPr id="14" name="Rectangle 13"/>
+          <p:cNvPr id="13" name="Rectangle 12"/>
           <p:cNvSpPr/>
           <p:nvPr/>
         </p:nvSpPr>
@@ -9317,7 +9478,7 @@
       </p:sp>
       <p:sp>
         <p:nvSpPr>
-          <p:cNvPr id="15" name="Rectangle 14"/>
+          <p:cNvPr id="14" name="Rectangle 13"/>
           <p:cNvSpPr/>
           <p:nvPr/>
         </p:nvSpPr>
@@ -9361,7 +9522,7 @@
       </p:sp>
       <p:sp>
         <p:nvSpPr>
-          <p:cNvPr id="16" name="TextBox 15"/>
+          <p:cNvPr id="15" name="TextBox 14"/>
           <p:cNvSpPr txBox="1"/>
           <p:nvPr/>
         </p:nvSpPr>
@@ -9400,7 +9561,7 @@
       </p:sp>
       <p:sp>
         <p:nvSpPr>
-          <p:cNvPr id="17" name="TextBox 16"/>
+          <p:cNvPr id="16" name="TextBox 15"/>
           <p:cNvSpPr txBox="1"/>
           <p:nvPr/>
         </p:nvSpPr>
@@ -9464,7 +9625,7 @@
       </p:sp>
       <p:sp>
         <p:nvSpPr>
-          <p:cNvPr id="18" name="Rectangle 17"/>
+          <p:cNvPr id="17" name="Rectangle 16"/>
           <p:cNvSpPr/>
           <p:nvPr/>
         </p:nvSpPr>
@@ -9510,7 +9671,7 @@
       </p:sp>
       <p:sp>
         <p:nvSpPr>
-          <p:cNvPr id="19" name="Rectangle 18"/>
+          <p:cNvPr id="18" name="Rectangle 17"/>
           <p:cNvSpPr/>
           <p:nvPr/>
         </p:nvSpPr>
@@ -9554,7 +9715,7 @@
       </p:sp>
       <p:sp>
         <p:nvSpPr>
-          <p:cNvPr id="20" name="TextBox 19"/>
+          <p:cNvPr id="19" name="TextBox 18"/>
           <p:cNvSpPr txBox="1"/>
           <p:nvPr/>
         </p:nvSpPr>
@@ -9593,7 +9754,7 @@
       </p:sp>
       <p:sp>
         <p:nvSpPr>
-          <p:cNvPr id="21" name="TextBox 20"/>
+          <p:cNvPr id="20" name="TextBox 19"/>
           <p:cNvSpPr txBox="1"/>
           <p:nvPr/>
         </p:nvSpPr>
@@ -9682,7 +9843,7 @@
       </p:sp>
       <p:sp>
         <p:nvSpPr>
-          <p:cNvPr id="22" name="Rectangle 21"/>
+          <p:cNvPr id="21" name="Rectangle 20"/>
           <p:cNvSpPr/>
           <p:nvPr/>
         </p:nvSpPr>
@@ -9728,7 +9889,7 @@
       </p:sp>
       <p:sp>
         <p:nvSpPr>
-          <p:cNvPr id="23" name="Rectangle 22"/>
+          <p:cNvPr id="22" name="Rectangle 21"/>
           <p:cNvSpPr/>
           <p:nvPr/>
         </p:nvSpPr>
@@ -9772,7 +9933,7 @@
       </p:sp>
       <p:sp>
         <p:nvSpPr>
-          <p:cNvPr id="24" name="TextBox 23"/>
+          <p:cNvPr id="23" name="TextBox 22"/>
           <p:cNvSpPr txBox="1"/>
           <p:nvPr/>
         </p:nvSpPr>
@@ -9811,7 +9972,7 @@
       </p:sp>
       <p:sp>
         <p:nvSpPr>
-          <p:cNvPr id="25" name="TextBox 24"/>
+          <p:cNvPr id="24" name="TextBox 23"/>
           <p:cNvSpPr txBox="1"/>
           <p:nvPr/>
         </p:nvSpPr>
@@ -9859,7 +10020,7 @@
       </p:sp>
       <p:sp>
         <p:nvSpPr>
-          <p:cNvPr id="26" name="Rectangle 25"/>
+          <p:cNvPr id="25" name="Rectangle 24"/>
           <p:cNvSpPr/>
           <p:nvPr/>
         </p:nvSpPr>
@@ -9905,7 +10066,7 @@
       </p:sp>
       <p:sp>
         <p:nvSpPr>
-          <p:cNvPr id="27" name="Rectangle 26"/>
+          <p:cNvPr id="26" name="Rectangle 25"/>
           <p:cNvSpPr/>
           <p:nvPr/>
         </p:nvSpPr>
@@ -9949,7 +10110,7 @@
       </p:sp>
       <p:sp>
         <p:nvSpPr>
-          <p:cNvPr id="28" name="TextBox 27"/>
+          <p:cNvPr id="27" name="TextBox 26"/>
           <p:cNvSpPr txBox="1"/>
           <p:nvPr/>
         </p:nvSpPr>
@@ -9988,7 +10149,7 @@
       </p:sp>
       <p:sp>
         <p:nvSpPr>
-          <p:cNvPr id="29" name="TextBox 28"/>
+          <p:cNvPr id="28" name="TextBox 27"/>
           <p:cNvSpPr txBox="1"/>
           <p:nvPr/>
         </p:nvSpPr>
@@ -10052,7 +10213,7 @@
       </p:sp>
       <p:sp>
         <p:nvSpPr>
-          <p:cNvPr id="30" name="Rectangle 29"/>
+          <p:cNvPr id="29" name="Rectangle 28"/>
           <p:cNvSpPr/>
           <p:nvPr/>
         </p:nvSpPr>
@@ -10098,7 +10259,7 @@
       </p:sp>
       <p:sp>
         <p:nvSpPr>
-          <p:cNvPr id="31" name="Rectangle 30"/>
+          <p:cNvPr id="30" name="Rectangle 29"/>
           <p:cNvSpPr/>
           <p:nvPr/>
         </p:nvSpPr>
@@ -10142,7 +10303,7 @@
       </p:sp>
       <p:sp>
         <p:nvSpPr>
-          <p:cNvPr id="32" name="TextBox 31"/>
+          <p:cNvPr id="31" name="TextBox 30"/>
           <p:cNvSpPr txBox="1"/>
           <p:nvPr/>
         </p:nvSpPr>
@@ -10181,7 +10342,7 @@
       </p:sp>
       <p:sp>
         <p:nvSpPr>
-          <p:cNvPr id="33" name="TextBox 32"/>
+          <p:cNvPr id="32" name="TextBox 31"/>
           <p:cNvSpPr txBox="1"/>
           <p:nvPr/>
         </p:nvSpPr>
@@ -10245,7 +10406,7 @@
       </p:sp>
       <p:sp>
         <p:nvSpPr>
-          <p:cNvPr id="34" name="Rectangle 33"/>
+          <p:cNvPr id="33" name="Rectangle 32"/>
           <p:cNvSpPr/>
           <p:nvPr/>
         </p:nvSpPr>
@@ -10291,7 +10452,7 @@
       </p:sp>
       <p:sp>
         <p:nvSpPr>
-          <p:cNvPr id="35" name="Rectangle 34"/>
+          <p:cNvPr id="34" name="Rectangle 33"/>
           <p:cNvSpPr/>
           <p:nvPr/>
         </p:nvSpPr>
@@ -10335,7 +10496,7 @@
       </p:sp>
       <p:sp>
         <p:nvSpPr>
-          <p:cNvPr id="36" name="TextBox 35"/>
+          <p:cNvPr id="35" name="TextBox 34"/>
           <p:cNvSpPr txBox="1"/>
           <p:nvPr/>
         </p:nvSpPr>
@@ -10374,7 +10535,7 @@
       </p:sp>
       <p:sp>
         <p:nvSpPr>
-          <p:cNvPr id="37" name="TextBox 36"/>
+          <p:cNvPr id="36" name="TextBox 35"/>
           <p:cNvSpPr txBox="1"/>
           <p:nvPr/>
         </p:nvSpPr>
@@ -10438,14 +10599,49 @@
       </p:sp>
       <p:cxnSp>
         <p:nvCxnSpPr>
+          <p:cNvPr id="37" name="Connector 36"/>
+          <p:cNvCxnSpPr/>
+          <p:nvPr/>
+        </p:nvCxnSpPr>
+        <p:spPr>
+          <a:xfrm>
+            <a:off x="1188720" y="2926080"/>
+            <a:ext cx="0" cy="1234440"/>
+          </a:xfrm>
+          <a:prstGeom prst="line">
+            <a:avLst/>
+          </a:prstGeom>
+          <a:ln w="25400">
+            <a:solidFill>
+              <a:srgbClr val="0F2430"/>
+            </a:solidFill>
+          </a:ln>
+        </p:spPr>
+        <p:style>
+          <a:lnRef idx="2">
+            <a:schemeClr val="accent1"/>
+          </a:lnRef>
+          <a:fillRef idx="0">
+            <a:schemeClr val="accent1"/>
+          </a:fillRef>
+          <a:effectRef idx="1">
+            <a:schemeClr val="accent1"/>
+          </a:effectRef>
+          <a:fontRef idx="minor">
+            <a:schemeClr val="tx1"/>
+          </a:fontRef>
+        </p:style>
+      </p:cxnSp>
+      <p:cxnSp>
+        <p:nvCxnSpPr>
           <p:cNvPr id="38" name="Connector 37"/>
           <p:cNvCxnSpPr/>
           <p:nvPr/>
         </p:nvCxnSpPr>
         <p:spPr>
           <a:xfrm>
-            <a:off x="1188720" y="2926080"/>
-            <a:ext cx="0" cy="1234440"/>
+            <a:off x="1069848" y="3035808"/>
+            <a:ext cx="237744" cy="0"/>
           </a:xfrm>
           <a:prstGeom prst="line">
             <a:avLst/>
@@ -10479,7 +10675,7 @@
         </p:nvCxnSpPr>
         <p:spPr>
           <a:xfrm>
-            <a:off x="1069848" y="3035808"/>
+            <a:off x="1069848" y="3127248"/>
             <a:ext cx="237744" cy="0"/>
           </a:xfrm>
           <a:prstGeom prst="line">
@@ -10514,7 +10710,7 @@
         </p:nvCxnSpPr>
         <p:spPr>
           <a:xfrm>
-            <a:off x="1069848" y="3127248"/>
+            <a:off x="1069848" y="4050792"/>
             <a:ext cx="237744" cy="0"/>
           </a:xfrm>
           <a:prstGeom prst="line">
@@ -10549,8 +10745,82 @@
         </p:nvCxnSpPr>
         <p:spPr>
           <a:xfrm>
-            <a:off x="1069848" y="4050792"/>
+            <a:off x="1069848" y="3959352"/>
             <a:ext cx="237744" cy="0"/>
+          </a:xfrm>
+          <a:prstGeom prst="line">
+            <a:avLst/>
+          </a:prstGeom>
+          <a:ln w="25400">
+            <a:solidFill>
+              <a:srgbClr val="0F2430"/>
+            </a:solidFill>
+          </a:ln>
+        </p:spPr>
+        <p:style>
+          <a:lnRef idx="2">
+            <a:schemeClr val="accent1"/>
+          </a:lnRef>
+          <a:fillRef idx="0">
+            <a:schemeClr val="accent1"/>
+          </a:fillRef>
+          <a:effectRef idx="1">
+            <a:schemeClr val="accent1"/>
+          </a:effectRef>
+          <a:fontRef idx="minor">
+            <a:schemeClr val="tx1"/>
+          </a:fontRef>
+        </p:style>
+      </p:cxnSp>
+      <p:sp>
+        <p:nvSpPr>
+          <p:cNvPr id="42" name="TextBox 41"/>
+          <p:cNvSpPr txBox="1"/>
+          <p:nvPr/>
+        </p:nvSpPr>
+        <p:spPr>
+          <a:xfrm>
+            <a:off x="1325880" y="3246120"/>
+            <a:ext cx="1188720" cy="320040"/>
+          </a:xfrm>
+          <a:prstGeom prst="rect">
+            <a:avLst/>
+          </a:prstGeom>
+          <a:noFill/>
+        </p:spPr>
+        <p:txBody>
+          <a:bodyPr wrap="square" lIns="0" rIns="0" tIns="0" bIns="0" anchor="t">
+            <a:spAutoFit/>
+          </a:bodyPr>
+          <a:lstStyle/>
+          <a:p>
+            <a:pPr algn="l">
+              <a:lnSpc>
+                <a:spcPct val="110000"/>
+              </a:lnSpc>
+            </a:pPr>
+            <a:r>
+              <a:rPr sz="1400" b="1">
+                <a:solidFill>
+                  <a:srgbClr val="1E6F63"/>
+                </a:solidFill>
+                <a:latin typeface="Segoe UI"/>
+              </a:rPr>
+              <a:t>becomes</a:t>
+            </a:r>
+          </a:p>
+        </p:txBody>
+      </p:sp>
+      <p:cxnSp>
+        <p:nvCxnSpPr>
+          <p:cNvPr id="43" name="Connector 42"/>
+          <p:cNvCxnSpPr/>
+          <p:nvPr/>
+        </p:nvCxnSpPr>
+        <p:spPr>
+          <a:xfrm>
+            <a:off x="3154680" y="2606040"/>
+            <a:ext cx="594360" cy="0"/>
           </a:xfrm>
           <a:prstGeom prst="line">
             <a:avLst/>
@@ -10578,88 +10848,14 @@
       </p:cxnSp>
       <p:cxnSp>
         <p:nvCxnSpPr>
-          <p:cNvPr id="42" name="Connector 41"/>
-          <p:cNvCxnSpPr/>
-          <p:nvPr/>
-        </p:nvCxnSpPr>
-        <p:spPr>
-          <a:xfrm>
-            <a:off x="1069848" y="3959352"/>
-            <a:ext cx="237744" cy="0"/>
-          </a:xfrm>
-          <a:prstGeom prst="line">
-            <a:avLst/>
-          </a:prstGeom>
-          <a:ln w="25400">
-            <a:solidFill>
-              <a:srgbClr val="0F2430"/>
-            </a:solidFill>
-          </a:ln>
-        </p:spPr>
-        <p:style>
-          <a:lnRef idx="2">
-            <a:schemeClr val="accent1"/>
-          </a:lnRef>
-          <a:fillRef idx="0">
-            <a:schemeClr val="accent1"/>
-          </a:fillRef>
-          <a:effectRef idx="1">
-            <a:schemeClr val="accent1"/>
-          </a:effectRef>
-          <a:fontRef idx="minor">
-            <a:schemeClr val="tx1"/>
-          </a:fontRef>
-        </p:style>
-      </p:cxnSp>
-      <p:sp>
-        <p:nvSpPr>
-          <p:cNvPr id="43" name="TextBox 42"/>
-          <p:cNvSpPr txBox="1"/>
-          <p:nvPr/>
-        </p:nvSpPr>
-        <p:spPr>
-          <a:xfrm>
-            <a:off x="1325880" y="3246120"/>
-            <a:ext cx="1188720" cy="320040"/>
-          </a:xfrm>
-          <a:prstGeom prst="rect">
-            <a:avLst/>
-          </a:prstGeom>
-          <a:noFill/>
-        </p:spPr>
-        <p:txBody>
-          <a:bodyPr wrap="square" lIns="0" rIns="0" tIns="0" bIns="0" anchor="t">
-            <a:spAutoFit/>
-          </a:bodyPr>
-          <a:lstStyle/>
-          <a:p>
-            <a:pPr algn="l">
-              <a:lnSpc>
-                <a:spcPct val="110000"/>
-              </a:lnSpc>
-            </a:pPr>
-            <a:r>
-              <a:rPr sz="1400" b="1">
-                <a:solidFill>
-                  <a:srgbClr val="1E6F63"/>
-                </a:solidFill>
-                <a:latin typeface="Segoe UI"/>
-              </a:rPr>
-              <a:t>becomes</a:t>
-            </a:r>
-          </a:p>
-        </p:txBody>
-      </p:sp>
-      <p:cxnSp>
-        <p:nvCxnSpPr>
           <p:cNvPr id="44" name="Connector 43"/>
           <p:cNvCxnSpPr/>
           <p:nvPr/>
         </p:nvCxnSpPr>
         <p:spPr>
           <a:xfrm>
-            <a:off x="3154680" y="2606040"/>
-            <a:ext cx="594360" cy="0"/>
+            <a:off x="3749040" y="2606040"/>
+            <a:ext cx="0" cy="1554480"/>
           </a:xfrm>
           <a:prstGeom prst="line">
             <a:avLst/>
@@ -10693,8 +10889,8 @@
         </p:nvCxnSpPr>
         <p:spPr>
           <a:xfrm>
-            <a:off x="3749040" y="2606040"/>
-            <a:ext cx="0" cy="1554480"/>
+            <a:off x="3749040" y="4160520"/>
+            <a:ext cx="749808" cy="0"/>
           </a:xfrm>
           <a:prstGeom prst="line">
             <a:avLst/>
@@ -10728,8 +10924,8 @@
         </p:nvCxnSpPr>
         <p:spPr>
           <a:xfrm>
-            <a:off x="3749040" y="4160520"/>
-            <a:ext cx="749808" cy="0"/>
+            <a:off x="3264408" y="2487168"/>
+            <a:ext cx="0" cy="237744"/>
           </a:xfrm>
           <a:prstGeom prst="line">
             <a:avLst/>
@@ -10763,7 +10959,7 @@
         </p:nvCxnSpPr>
         <p:spPr>
           <a:xfrm>
-            <a:off x="3264408" y="2487168"/>
+            <a:off x="3355848" y="2487168"/>
             <a:ext cx="0" cy="237744"/>
           </a:xfrm>
           <a:prstGeom prst="line">
@@ -10797,9 +10993,9 @@
           <p:nvPr/>
         </p:nvCxnSpPr>
         <p:spPr>
-          <a:xfrm>
-            <a:off x="3355848" y="2487168"/>
-            <a:ext cx="0" cy="237744"/>
+          <a:xfrm flipV="1">
+            <a:off x="4224528" y="4014216"/>
+            <a:ext cx="274320" cy="146304"/>
           </a:xfrm>
           <a:prstGeom prst="line">
             <a:avLst/>
@@ -10832,9 +11028,9 @@
           <p:nvPr/>
         </p:nvCxnSpPr>
         <p:spPr>
-          <a:xfrm flipV="1">
-            <a:off x="4224528" y="4014216"/>
-            <a:ext cx="274320" cy="146304"/>
+          <a:xfrm>
+            <a:off x="4224528" y="4160520"/>
+            <a:ext cx="274320" cy="0"/>
           </a:xfrm>
           <a:prstGeom prst="line">
             <a:avLst/>
@@ -10869,7 +11065,81 @@
         <p:spPr>
           <a:xfrm>
             <a:off x="4224528" y="4160520"/>
-            <a:ext cx="274320" cy="0"/>
+            <a:ext cx="274320" cy="146304"/>
+          </a:xfrm>
+          <a:prstGeom prst="line">
+            <a:avLst/>
+          </a:prstGeom>
+          <a:ln w="25400">
+            <a:solidFill>
+              <a:srgbClr val="0F2430"/>
+            </a:solidFill>
+          </a:ln>
+        </p:spPr>
+        <p:style>
+          <a:lnRef idx="2">
+            <a:schemeClr val="accent1"/>
+          </a:lnRef>
+          <a:fillRef idx="0">
+            <a:schemeClr val="accent1"/>
+          </a:fillRef>
+          <a:effectRef idx="1">
+            <a:schemeClr val="accent1"/>
+          </a:effectRef>
+          <a:fontRef idx="minor">
+            <a:schemeClr val="tx1"/>
+          </a:fontRef>
+        </p:style>
+      </p:cxnSp>
+      <p:sp>
+        <p:nvSpPr>
+          <p:cNvPr id="51" name="TextBox 50"/>
+          <p:cNvSpPr txBox="1"/>
+          <p:nvPr/>
+        </p:nvSpPr>
+        <p:spPr>
+          <a:xfrm>
+            <a:off x="3264408" y="2221992"/>
+            <a:ext cx="1188720" cy="320040"/>
+          </a:xfrm>
+          <a:prstGeom prst="rect">
+            <a:avLst/>
+          </a:prstGeom>
+          <a:noFill/>
+        </p:spPr>
+        <p:txBody>
+          <a:bodyPr wrap="square" lIns="0" rIns="0" tIns="0" bIns="0" anchor="t">
+            <a:spAutoFit/>
+          </a:bodyPr>
+          <a:lstStyle/>
+          <a:p>
+            <a:pPr algn="l">
+              <a:lnSpc>
+                <a:spcPct val="110000"/>
+              </a:lnSpc>
+            </a:pPr>
+            <a:r>
+              <a:rPr sz="1400" b="1">
+                <a:solidFill>
+                  <a:srgbClr val="1E6F63"/>
+                </a:solidFill>
+                <a:latin typeface="Segoe UI"/>
+              </a:rPr>
+              <a:t>creates</a:t>
+            </a:r>
+          </a:p>
+        </p:txBody>
+      </p:sp>
+      <p:cxnSp>
+        <p:nvCxnSpPr>
+          <p:cNvPr id="52" name="Connector 51"/>
+          <p:cNvCxnSpPr/>
+          <p:nvPr/>
+        </p:nvCxnSpPr>
+        <p:spPr>
+          <a:xfrm>
+            <a:off x="3154680" y="4526280"/>
+            <a:ext cx="1344168" cy="0"/>
           </a:xfrm>
           <a:prstGeom prst="line">
             <a:avLst/>
@@ -10897,88 +11167,14 @@
       </p:cxnSp>
       <p:cxnSp>
         <p:nvCxnSpPr>
-          <p:cNvPr id="51" name="Connector 50"/>
-          <p:cNvCxnSpPr/>
-          <p:nvPr/>
-        </p:nvCxnSpPr>
-        <p:spPr>
-          <a:xfrm>
-            <a:off x="4224528" y="4160520"/>
-            <a:ext cx="274320" cy="146304"/>
-          </a:xfrm>
-          <a:prstGeom prst="line">
-            <a:avLst/>
-          </a:prstGeom>
-          <a:ln w="25400">
-            <a:solidFill>
-              <a:srgbClr val="0F2430"/>
-            </a:solidFill>
-          </a:ln>
-        </p:spPr>
-        <p:style>
-          <a:lnRef idx="2">
-            <a:schemeClr val="accent1"/>
-          </a:lnRef>
-          <a:fillRef idx="0">
-            <a:schemeClr val="accent1"/>
-          </a:fillRef>
-          <a:effectRef idx="1">
-            <a:schemeClr val="accent1"/>
-          </a:effectRef>
-          <a:fontRef idx="minor">
-            <a:schemeClr val="tx1"/>
-          </a:fontRef>
-        </p:style>
-      </p:cxnSp>
-      <p:sp>
-        <p:nvSpPr>
-          <p:cNvPr id="52" name="TextBox 51"/>
-          <p:cNvSpPr txBox="1"/>
-          <p:nvPr/>
-        </p:nvSpPr>
-        <p:spPr>
-          <a:xfrm>
-            <a:off x="3264408" y="2221992"/>
-            <a:ext cx="1188720" cy="320040"/>
-          </a:xfrm>
-          <a:prstGeom prst="rect">
-            <a:avLst/>
-          </a:prstGeom>
-          <a:noFill/>
-        </p:spPr>
-        <p:txBody>
-          <a:bodyPr wrap="square" lIns="0" rIns="0" tIns="0" bIns="0" anchor="t">
-            <a:spAutoFit/>
-          </a:bodyPr>
-          <a:lstStyle/>
-          <a:p>
-            <a:pPr algn="l">
-              <a:lnSpc>
-                <a:spcPct val="110000"/>
-              </a:lnSpc>
-            </a:pPr>
-            <a:r>
-              <a:rPr sz="1400" b="1">
-                <a:solidFill>
-                  <a:srgbClr val="1E6F63"/>
-                </a:solidFill>
-                <a:latin typeface="Segoe UI"/>
-              </a:rPr>
-              <a:t>creates</a:t>
-            </a:r>
-          </a:p>
-        </p:txBody>
-      </p:sp>
-      <p:cxnSp>
-        <p:nvCxnSpPr>
           <p:cNvPr id="53" name="Connector 52"/>
           <p:cNvCxnSpPr/>
           <p:nvPr/>
         </p:nvCxnSpPr>
         <p:spPr>
           <a:xfrm>
-            <a:off x="3154680" y="4526280"/>
-            <a:ext cx="1344168" cy="0"/>
+            <a:off x="3264408" y="4407408"/>
+            <a:ext cx="0" cy="237744"/>
           </a:xfrm>
           <a:prstGeom prst="line">
             <a:avLst/>
@@ -11012,7 +11208,7 @@
         </p:nvCxnSpPr>
         <p:spPr>
           <a:xfrm>
-            <a:off x="3264408" y="4407408"/>
+            <a:off x="3355848" y="4407408"/>
             <a:ext cx="0" cy="237744"/>
           </a:xfrm>
           <a:prstGeom prst="line">
@@ -11046,9 +11242,9 @@
           <p:nvPr/>
         </p:nvCxnSpPr>
         <p:spPr>
-          <a:xfrm>
-            <a:off x="3355848" y="4407408"/>
-            <a:ext cx="0" cy="237744"/>
+          <a:xfrm flipV="1">
+            <a:off x="4224528" y="4379976"/>
+            <a:ext cx="274320" cy="146304"/>
           </a:xfrm>
           <a:prstGeom prst="line">
             <a:avLst/>
@@ -11081,9 +11277,9 @@
           <p:nvPr/>
         </p:nvCxnSpPr>
         <p:spPr>
-          <a:xfrm flipV="1">
-            <a:off x="4224528" y="4379976"/>
-            <a:ext cx="274320" cy="146304"/>
+          <a:xfrm>
+            <a:off x="4224528" y="4526280"/>
+            <a:ext cx="274320" cy="0"/>
           </a:xfrm>
           <a:prstGeom prst="line">
             <a:avLst/>
@@ -11118,7 +11314,81 @@
         <p:spPr>
           <a:xfrm>
             <a:off x="4224528" y="4526280"/>
-            <a:ext cx="274320" cy="0"/>
+            <a:ext cx="274320" cy="146304"/>
+          </a:xfrm>
+          <a:prstGeom prst="line">
+            <a:avLst/>
+          </a:prstGeom>
+          <a:ln w="25400">
+            <a:solidFill>
+              <a:srgbClr val="0F2430"/>
+            </a:solidFill>
+          </a:ln>
+        </p:spPr>
+        <p:style>
+          <a:lnRef idx="2">
+            <a:schemeClr val="accent1"/>
+          </a:lnRef>
+          <a:fillRef idx="0">
+            <a:schemeClr val="accent1"/>
+          </a:fillRef>
+          <a:effectRef idx="1">
+            <a:schemeClr val="accent1"/>
+          </a:effectRef>
+          <a:fontRef idx="minor">
+            <a:schemeClr val="tx1"/>
+          </a:fontRef>
+        </p:style>
+      </p:cxnSp>
+      <p:sp>
+        <p:nvSpPr>
+          <p:cNvPr id="58" name="TextBox 57"/>
+          <p:cNvSpPr txBox="1"/>
+          <p:nvPr/>
+        </p:nvSpPr>
+        <p:spPr>
+          <a:xfrm>
+            <a:off x="3520440" y="4142232"/>
+            <a:ext cx="1188720" cy="320040"/>
+          </a:xfrm>
+          <a:prstGeom prst="rect">
+            <a:avLst/>
+          </a:prstGeom>
+          <a:noFill/>
+        </p:spPr>
+        <p:txBody>
+          <a:bodyPr wrap="square" lIns="0" rIns="0" tIns="0" bIns="0" anchor="t">
+            <a:spAutoFit/>
+          </a:bodyPr>
+          <a:lstStyle/>
+          <a:p>
+            <a:pPr algn="l">
+              <a:lnSpc>
+                <a:spcPct val="110000"/>
+              </a:lnSpc>
+            </a:pPr>
+            <a:r>
+              <a:rPr sz="1400" b="1">
+                <a:solidFill>
+                  <a:srgbClr val="1E6F63"/>
+                </a:solidFill>
+                <a:latin typeface="Segoe UI"/>
+              </a:rPr>
+              <a:t>repairs</a:t>
+            </a:r>
+          </a:p>
+        </p:txBody>
+      </p:sp>
+      <p:cxnSp>
+        <p:nvCxnSpPr>
+          <p:cNvPr id="59" name="Connector 58"/>
+          <p:cNvCxnSpPr/>
+          <p:nvPr/>
+        </p:nvCxnSpPr>
+        <p:spPr>
+          <a:xfrm>
+            <a:off x="2606040" y="5650992"/>
+            <a:ext cx="0" cy="384048"/>
           </a:xfrm>
           <a:prstGeom prst="line">
             <a:avLst/>
@@ -11146,88 +11416,14 @@
       </p:cxnSp>
       <p:cxnSp>
         <p:nvCxnSpPr>
-          <p:cNvPr id="58" name="Connector 57"/>
-          <p:cNvCxnSpPr/>
-          <p:nvPr/>
-        </p:nvCxnSpPr>
-        <p:spPr>
-          <a:xfrm>
-            <a:off x="4224528" y="4526280"/>
-            <a:ext cx="274320" cy="146304"/>
-          </a:xfrm>
-          <a:prstGeom prst="line">
-            <a:avLst/>
-          </a:prstGeom>
-          <a:ln w="25400">
-            <a:solidFill>
-              <a:srgbClr val="0F2430"/>
-            </a:solidFill>
-          </a:ln>
-        </p:spPr>
-        <p:style>
-          <a:lnRef idx="2">
-            <a:schemeClr val="accent1"/>
-          </a:lnRef>
-          <a:fillRef idx="0">
-            <a:schemeClr val="accent1"/>
-          </a:fillRef>
-          <a:effectRef idx="1">
-            <a:schemeClr val="accent1"/>
-          </a:effectRef>
-          <a:fontRef idx="minor">
-            <a:schemeClr val="tx1"/>
-          </a:fontRef>
-        </p:style>
-      </p:cxnSp>
-      <p:sp>
-        <p:nvSpPr>
-          <p:cNvPr id="59" name="TextBox 58"/>
-          <p:cNvSpPr txBox="1"/>
-          <p:nvPr/>
-        </p:nvSpPr>
-        <p:spPr>
-          <a:xfrm>
-            <a:off x="3520440" y="4142232"/>
-            <a:ext cx="1188720" cy="320040"/>
-          </a:xfrm>
-          <a:prstGeom prst="rect">
-            <a:avLst/>
-          </a:prstGeom>
-          <a:noFill/>
-        </p:spPr>
-        <p:txBody>
-          <a:bodyPr wrap="square" lIns="0" rIns="0" tIns="0" bIns="0" anchor="t">
-            <a:spAutoFit/>
-          </a:bodyPr>
-          <a:lstStyle/>
-          <a:p>
-            <a:pPr algn="l">
-              <a:lnSpc>
-                <a:spcPct val="110000"/>
-              </a:lnSpc>
-            </a:pPr>
-            <a:r>
-              <a:rPr sz="1400" b="1">
-                <a:solidFill>
-                  <a:srgbClr val="1E6F63"/>
-                </a:solidFill>
-                <a:latin typeface="Segoe UI"/>
-              </a:rPr>
-              <a:t>repairs</a:t>
-            </a:r>
-          </a:p>
-        </p:txBody>
-      </p:sp>
-      <p:cxnSp>
-        <p:nvCxnSpPr>
           <p:cNvPr id="60" name="Connector 59"/>
           <p:cNvCxnSpPr/>
           <p:nvPr/>
         </p:nvCxnSpPr>
         <p:spPr>
           <a:xfrm>
-            <a:off x="2606040" y="5650992"/>
-            <a:ext cx="0" cy="384048"/>
+            <a:off x="2606040" y="6035040"/>
+            <a:ext cx="1892808" cy="0"/>
           </a:xfrm>
           <a:prstGeom prst="line">
             <a:avLst/>
@@ -11261,8 +11457,8 @@
         </p:nvCxnSpPr>
         <p:spPr>
           <a:xfrm>
-            <a:off x="2606040" y="6035040"/>
-            <a:ext cx="1892808" cy="0"/>
+            <a:off x="2487168" y="5760720"/>
+            <a:ext cx="237744" cy="0"/>
           </a:xfrm>
           <a:prstGeom prst="line">
             <a:avLst/>
@@ -11296,7 +11492,7 @@
         </p:nvCxnSpPr>
         <p:spPr>
           <a:xfrm>
-            <a:off x="2487168" y="5760720"/>
+            <a:off x="2487168" y="5852160"/>
             <a:ext cx="237744" cy="0"/>
           </a:xfrm>
           <a:prstGeom prst="line">
@@ -11330,9 +11526,9 @@
           <p:nvPr/>
         </p:nvCxnSpPr>
         <p:spPr>
-          <a:xfrm>
-            <a:off x="2487168" y="5852160"/>
-            <a:ext cx="237744" cy="0"/>
+          <a:xfrm flipV="1">
+            <a:off x="4224528" y="5888736"/>
+            <a:ext cx="274320" cy="146304"/>
           </a:xfrm>
           <a:prstGeom prst="line">
             <a:avLst/>
@@ -11365,9 +11561,9 @@
           <p:nvPr/>
         </p:nvCxnSpPr>
         <p:spPr>
-          <a:xfrm flipV="1">
-            <a:off x="4224528" y="5888736"/>
-            <a:ext cx="274320" cy="146304"/>
+          <a:xfrm>
+            <a:off x="4224528" y="6035040"/>
+            <a:ext cx="274320" cy="0"/>
           </a:xfrm>
           <a:prstGeom prst="line">
             <a:avLst/>
@@ -11402,7 +11598,81 @@
         <p:spPr>
           <a:xfrm>
             <a:off x="4224528" y="6035040"/>
-            <a:ext cx="274320" cy="0"/>
+            <a:ext cx="274320" cy="146304"/>
+          </a:xfrm>
+          <a:prstGeom prst="line">
+            <a:avLst/>
+          </a:prstGeom>
+          <a:ln w="25400">
+            <a:solidFill>
+              <a:srgbClr val="0F2430"/>
+            </a:solidFill>
+          </a:ln>
+        </p:spPr>
+        <p:style>
+          <a:lnRef idx="2">
+            <a:schemeClr val="accent1"/>
+          </a:lnRef>
+          <a:fillRef idx="0">
+            <a:schemeClr val="accent1"/>
+          </a:fillRef>
+          <a:effectRef idx="1">
+            <a:schemeClr val="accent1"/>
+          </a:effectRef>
+          <a:fontRef idx="minor">
+            <a:schemeClr val="tx1"/>
+          </a:fontRef>
+        </p:style>
+      </p:cxnSp>
+      <p:sp>
+        <p:nvSpPr>
+          <p:cNvPr id="66" name="TextBox 65"/>
+          <p:cNvSpPr txBox="1"/>
+          <p:nvPr/>
+        </p:nvSpPr>
+        <p:spPr>
+          <a:xfrm>
+            <a:off x="2743200" y="5650992"/>
+            <a:ext cx="1188720" cy="320040"/>
+          </a:xfrm>
+          <a:prstGeom prst="rect">
+            <a:avLst/>
+          </a:prstGeom>
+          <a:noFill/>
+        </p:spPr>
+        <p:txBody>
+          <a:bodyPr wrap="square" lIns="0" rIns="0" tIns="0" bIns="0" anchor="t">
+            <a:spAutoFit/>
+          </a:bodyPr>
+          <a:lstStyle/>
+          <a:p>
+            <a:pPr algn="l">
+              <a:lnSpc>
+                <a:spcPct val="110000"/>
+              </a:lnSpc>
+            </a:pPr>
+            <a:r>
+              <a:rPr sz="1400" b="1">
+                <a:solidFill>
+                  <a:srgbClr val="1E6F63"/>
+                </a:solidFill>
+                <a:latin typeface="Segoe UI"/>
+              </a:rPr>
+              <a:t>sends</a:t>
+            </a:r>
+          </a:p>
+        </p:txBody>
+      </p:sp>
+      <p:cxnSp>
+        <p:nvCxnSpPr>
+          <p:cNvPr id="67" name="Connector 66"/>
+          <p:cNvCxnSpPr/>
+          <p:nvPr/>
+        </p:nvCxnSpPr>
+        <p:spPr>
+          <a:xfrm>
+            <a:off x="6053328" y="2926080"/>
+            <a:ext cx="0" cy="502920"/>
           </a:xfrm>
           <a:prstGeom prst="line">
             <a:avLst/>
@@ -11430,88 +11700,14 @@
       </p:cxnSp>
       <p:cxnSp>
         <p:nvCxnSpPr>
-          <p:cNvPr id="66" name="Connector 65"/>
-          <p:cNvCxnSpPr/>
-          <p:nvPr/>
-        </p:nvCxnSpPr>
-        <p:spPr>
-          <a:xfrm>
-            <a:off x="4224528" y="6035040"/>
-            <a:ext cx="274320" cy="146304"/>
-          </a:xfrm>
-          <a:prstGeom prst="line">
-            <a:avLst/>
-          </a:prstGeom>
-          <a:ln w="25400">
-            <a:solidFill>
-              <a:srgbClr val="0F2430"/>
-            </a:solidFill>
-          </a:ln>
-        </p:spPr>
-        <p:style>
-          <a:lnRef idx="2">
-            <a:schemeClr val="accent1"/>
-          </a:lnRef>
-          <a:fillRef idx="0">
-            <a:schemeClr val="accent1"/>
-          </a:fillRef>
-          <a:effectRef idx="1">
-            <a:schemeClr val="accent1"/>
-          </a:effectRef>
-          <a:fontRef idx="minor">
-            <a:schemeClr val="tx1"/>
-          </a:fontRef>
-        </p:style>
-      </p:cxnSp>
-      <p:sp>
-        <p:nvSpPr>
-          <p:cNvPr id="67" name="TextBox 66"/>
-          <p:cNvSpPr txBox="1"/>
-          <p:nvPr/>
-        </p:nvSpPr>
-        <p:spPr>
-          <a:xfrm>
-            <a:off x="2743200" y="5650992"/>
-            <a:ext cx="1188720" cy="320040"/>
-          </a:xfrm>
-          <a:prstGeom prst="rect">
-            <a:avLst/>
-          </a:prstGeom>
-          <a:noFill/>
-        </p:spPr>
-        <p:txBody>
-          <a:bodyPr wrap="square" lIns="0" rIns="0" tIns="0" bIns="0" anchor="t">
-            <a:spAutoFit/>
-          </a:bodyPr>
-          <a:lstStyle/>
-          <a:p>
-            <a:pPr algn="l">
-              <a:lnSpc>
-                <a:spcPct val="110000"/>
-              </a:lnSpc>
-            </a:pPr>
-            <a:r>
-              <a:rPr sz="1400" b="1">
-                <a:solidFill>
-                  <a:srgbClr val="1E6F63"/>
-                </a:solidFill>
-                <a:latin typeface="Segoe UI"/>
-              </a:rPr>
-              <a:t>sends</a:t>
-            </a:r>
-          </a:p>
-        </p:txBody>
-      </p:sp>
-      <p:cxnSp>
-        <p:nvCxnSpPr>
           <p:cNvPr id="68" name="Connector 67"/>
           <p:cNvCxnSpPr/>
           <p:nvPr/>
         </p:nvCxnSpPr>
         <p:spPr>
           <a:xfrm>
-            <a:off x="6053328" y="2926080"/>
-            <a:ext cx="0" cy="502920"/>
+            <a:off x="5934456" y="3035808"/>
+            <a:ext cx="237744" cy="0"/>
           </a:xfrm>
           <a:prstGeom prst="line">
             <a:avLst/>
@@ -11545,7 +11741,7 @@
         </p:nvCxnSpPr>
         <p:spPr>
           <a:xfrm>
-            <a:off x="5934456" y="3035808"/>
+            <a:off x="5934456" y="3127248"/>
             <a:ext cx="237744" cy="0"/>
           </a:xfrm>
           <a:prstGeom prst="line">
@@ -11579,9 +11775,9 @@
           <p:nvPr/>
         </p:nvCxnSpPr>
         <p:spPr>
-          <a:xfrm>
-            <a:off x="5934456" y="3127248"/>
-            <a:ext cx="237744" cy="0"/>
+          <a:xfrm flipH="1">
+            <a:off x="5907024" y="3154680"/>
+            <a:ext cx="146304" cy="274320"/>
           </a:xfrm>
           <a:prstGeom prst="line">
             <a:avLst/>
@@ -11614,9 +11810,9 @@
           <p:nvPr/>
         </p:nvCxnSpPr>
         <p:spPr>
-          <a:xfrm flipH="1">
-            <a:off x="5907024" y="3154680"/>
-            <a:ext cx="146304" cy="274320"/>
+          <a:xfrm>
+            <a:off x="6053328" y="3154680"/>
+            <a:ext cx="0" cy="274320"/>
           </a:xfrm>
           <a:prstGeom prst="line">
             <a:avLst/>
@@ -11651,7 +11847,81 @@
         <p:spPr>
           <a:xfrm>
             <a:off x="6053328" y="3154680"/>
-            <a:ext cx="0" cy="274320"/>
+            <a:ext cx="146304" cy="274320"/>
+          </a:xfrm>
+          <a:prstGeom prst="line">
+            <a:avLst/>
+          </a:prstGeom>
+          <a:ln w="25400">
+            <a:solidFill>
+              <a:srgbClr val="0F2430"/>
+            </a:solidFill>
+          </a:ln>
+        </p:spPr>
+        <p:style>
+          <a:lnRef idx="2">
+            <a:schemeClr val="accent1"/>
+          </a:lnRef>
+          <a:fillRef idx="0">
+            <a:schemeClr val="accent1"/>
+          </a:fillRef>
+          <a:effectRef idx="1">
+            <a:schemeClr val="accent1"/>
+          </a:effectRef>
+          <a:fontRef idx="minor">
+            <a:schemeClr val="tx1"/>
+          </a:fontRef>
+        </p:style>
+      </p:cxnSp>
+      <p:sp>
+        <p:nvSpPr>
+          <p:cNvPr id="73" name="TextBox 72"/>
+          <p:cNvSpPr txBox="1"/>
+          <p:nvPr/>
+        </p:nvSpPr>
+        <p:spPr>
+          <a:xfrm>
+            <a:off x="6327648" y="3017520"/>
+            <a:ext cx="1188720" cy="320040"/>
+          </a:xfrm>
+          <a:prstGeom prst="rect">
+            <a:avLst/>
+          </a:prstGeom>
+          <a:noFill/>
+        </p:spPr>
+        <p:txBody>
+          <a:bodyPr wrap="square" lIns="0" rIns="0" tIns="0" bIns="0" anchor="t">
+            <a:spAutoFit/>
+          </a:bodyPr>
+          <a:lstStyle/>
+          <a:p>
+            <a:pPr algn="l">
+              <a:lnSpc>
+                <a:spcPct val="110000"/>
+              </a:lnSpc>
+            </a:pPr>
+            <a:r>
+              <a:rPr sz="1400" b="1">
+                <a:solidFill>
+                  <a:srgbClr val="1E6F63"/>
+                </a:solidFill>
+                <a:latin typeface="Segoe UI"/>
+              </a:rPr>
+              <a:t>priced by</a:t>
+            </a:r>
+          </a:p>
+        </p:txBody>
+      </p:sp>
+      <p:cxnSp>
+        <p:nvCxnSpPr>
+          <p:cNvPr id="74" name="Connector 73"/>
+          <p:cNvCxnSpPr/>
+          <p:nvPr/>
+        </p:nvCxnSpPr>
+        <p:spPr>
+          <a:xfrm>
+            <a:off x="6053328" y="4919472"/>
+            <a:ext cx="0" cy="429768"/>
           </a:xfrm>
           <a:prstGeom prst="line">
             <a:avLst/>
@@ -11679,88 +11949,14 @@
       </p:cxnSp>
       <p:cxnSp>
         <p:nvCxnSpPr>
-          <p:cNvPr id="73" name="Connector 72"/>
-          <p:cNvCxnSpPr/>
-          <p:nvPr/>
-        </p:nvCxnSpPr>
-        <p:spPr>
-          <a:xfrm>
-            <a:off x="6053328" y="3154680"/>
-            <a:ext cx="146304" cy="274320"/>
-          </a:xfrm>
-          <a:prstGeom prst="line">
-            <a:avLst/>
-          </a:prstGeom>
-          <a:ln w="25400">
-            <a:solidFill>
-              <a:srgbClr val="0F2430"/>
-            </a:solidFill>
-          </a:ln>
-        </p:spPr>
-        <p:style>
-          <a:lnRef idx="2">
-            <a:schemeClr val="accent1"/>
-          </a:lnRef>
-          <a:fillRef idx="0">
-            <a:schemeClr val="accent1"/>
-          </a:fillRef>
-          <a:effectRef idx="1">
-            <a:schemeClr val="accent1"/>
-          </a:effectRef>
-          <a:fontRef idx="minor">
-            <a:schemeClr val="tx1"/>
-          </a:fontRef>
-        </p:style>
-      </p:cxnSp>
-      <p:sp>
-        <p:nvSpPr>
-          <p:cNvPr id="74" name="TextBox 73"/>
-          <p:cNvSpPr txBox="1"/>
-          <p:nvPr/>
-        </p:nvSpPr>
-        <p:spPr>
-          <a:xfrm>
-            <a:off x="6327648" y="3017520"/>
-            <a:ext cx="1188720" cy="320040"/>
-          </a:xfrm>
-          <a:prstGeom prst="rect">
-            <a:avLst/>
-          </a:prstGeom>
-          <a:noFill/>
-        </p:spPr>
-        <p:txBody>
-          <a:bodyPr wrap="square" lIns="0" rIns="0" tIns="0" bIns="0" anchor="t">
-            <a:spAutoFit/>
-          </a:bodyPr>
-          <a:lstStyle/>
-          <a:p>
-            <a:pPr algn="l">
-              <a:lnSpc>
-                <a:spcPct val="110000"/>
-              </a:lnSpc>
-            </a:pPr>
-            <a:r>
-              <a:rPr sz="1400" b="1">
-                <a:solidFill>
-                  <a:srgbClr val="1E6F63"/>
-                </a:solidFill>
-                <a:latin typeface="Segoe UI"/>
-              </a:rPr>
-              <a:t>priced by</a:t>
-            </a:r>
-          </a:p>
-        </p:txBody>
-      </p:sp>
-      <p:cxnSp>
-        <p:nvCxnSpPr>
           <p:cNvPr id="75" name="Connector 74"/>
           <p:cNvCxnSpPr/>
           <p:nvPr/>
         </p:nvCxnSpPr>
         <p:spPr>
           <a:xfrm>
-            <a:off x="6053328" y="4919472"/>
-            <a:ext cx="0" cy="429768"/>
+            <a:off x="5934456" y="5029200"/>
+            <a:ext cx="237744" cy="0"/>
           </a:xfrm>
           <a:prstGeom prst="line">
             <a:avLst/>
@@ -11794,7 +11990,7 @@
         </p:nvCxnSpPr>
         <p:spPr>
           <a:xfrm>
-            <a:off x="5934456" y="5029200"/>
+            <a:off x="5934456" y="5120640"/>
             <a:ext cx="237744" cy="0"/>
           </a:xfrm>
           <a:prstGeom prst="line">
@@ -11828,9 +12024,9 @@
           <p:nvPr/>
         </p:nvCxnSpPr>
         <p:spPr>
-          <a:xfrm>
-            <a:off x="5934456" y="5120640"/>
-            <a:ext cx="237744" cy="0"/>
+          <a:xfrm flipH="1">
+            <a:off x="5907024" y="5074920"/>
+            <a:ext cx="146304" cy="274320"/>
           </a:xfrm>
           <a:prstGeom prst="line">
             <a:avLst/>
@@ -11863,9 +12059,9 @@
           <p:nvPr/>
         </p:nvCxnSpPr>
         <p:spPr>
-          <a:xfrm flipH="1">
-            <a:off x="5907024" y="5074920"/>
-            <a:ext cx="146304" cy="274320"/>
+          <a:xfrm>
+            <a:off x="6053328" y="5074920"/>
+            <a:ext cx="0" cy="274320"/>
           </a:xfrm>
           <a:prstGeom prst="line">
             <a:avLst/>
@@ -11900,7 +12096,81 @@
         <p:spPr>
           <a:xfrm>
             <a:off x="6053328" y="5074920"/>
-            <a:ext cx="0" cy="274320"/>
+            <a:ext cx="146304" cy="274320"/>
+          </a:xfrm>
+          <a:prstGeom prst="line">
+            <a:avLst/>
+          </a:prstGeom>
+          <a:ln w="25400">
+            <a:solidFill>
+              <a:srgbClr val="0F2430"/>
+            </a:solidFill>
+          </a:ln>
+        </p:spPr>
+        <p:style>
+          <a:lnRef idx="2">
+            <a:schemeClr val="accent1"/>
+          </a:lnRef>
+          <a:fillRef idx="0">
+            <a:schemeClr val="accent1"/>
+          </a:fillRef>
+          <a:effectRef idx="1">
+            <a:schemeClr val="accent1"/>
+          </a:effectRef>
+          <a:fontRef idx="minor">
+            <a:schemeClr val="tx1"/>
+          </a:fontRef>
+        </p:style>
+      </p:cxnSp>
+      <p:sp>
+        <p:nvSpPr>
+          <p:cNvPr id="80" name="TextBox 79"/>
+          <p:cNvSpPr txBox="1"/>
+          <p:nvPr/>
+        </p:nvSpPr>
+        <p:spPr>
+          <a:xfrm>
+            <a:off x="6327648" y="4974336"/>
+            <a:ext cx="1188720" cy="320040"/>
+          </a:xfrm>
+          <a:prstGeom prst="rect">
+            <a:avLst/>
+          </a:prstGeom>
+          <a:noFill/>
+        </p:spPr>
+        <p:txBody>
+          <a:bodyPr wrap="square" lIns="0" rIns="0" tIns="0" bIns="0" anchor="t">
+            <a:spAutoFit/>
+          </a:bodyPr>
+          <a:lstStyle/>
+          <a:p>
+            <a:pPr algn="l">
+              <a:lnSpc>
+                <a:spcPct val="110000"/>
+              </a:lnSpc>
+            </a:pPr>
+            <a:r>
+              <a:rPr sz="1400" b="1">
+                <a:solidFill>
+                  <a:srgbClr val="1E6F63"/>
+                </a:solidFill>
+                <a:latin typeface="Segoe UI"/>
+              </a:rPr>
+              <a:t>gets</a:t>
+            </a:r>
+          </a:p>
+        </p:txBody>
+      </p:sp>
+      <p:cxnSp>
+        <p:nvCxnSpPr>
+          <p:cNvPr id="81" name="Connector 80"/>
+          <p:cNvCxnSpPr/>
+          <p:nvPr/>
+        </p:nvCxnSpPr>
+        <p:spPr>
+          <a:xfrm>
+            <a:off x="7607808" y="3703320"/>
+            <a:ext cx="877824" cy="0"/>
           </a:xfrm>
           <a:prstGeom prst="line">
             <a:avLst/>
@@ -11928,88 +12198,14 @@
       </p:cxnSp>
       <p:cxnSp>
         <p:nvCxnSpPr>
-          <p:cNvPr id="80" name="Connector 79"/>
-          <p:cNvCxnSpPr/>
-          <p:nvPr/>
-        </p:nvCxnSpPr>
-        <p:spPr>
-          <a:xfrm>
-            <a:off x="6053328" y="5074920"/>
-            <a:ext cx="146304" cy="274320"/>
-          </a:xfrm>
-          <a:prstGeom prst="line">
-            <a:avLst/>
-          </a:prstGeom>
-          <a:ln w="25400">
-            <a:solidFill>
-              <a:srgbClr val="0F2430"/>
-            </a:solidFill>
-          </a:ln>
-        </p:spPr>
-        <p:style>
-          <a:lnRef idx="2">
-            <a:schemeClr val="accent1"/>
-          </a:lnRef>
-          <a:fillRef idx="0">
-            <a:schemeClr val="accent1"/>
-          </a:fillRef>
-          <a:effectRef idx="1">
-            <a:schemeClr val="accent1"/>
-          </a:effectRef>
-          <a:fontRef idx="minor">
-            <a:schemeClr val="tx1"/>
-          </a:fontRef>
-        </p:style>
-      </p:cxnSp>
-      <p:sp>
-        <p:nvSpPr>
-          <p:cNvPr id="81" name="TextBox 80"/>
-          <p:cNvSpPr txBox="1"/>
-          <p:nvPr/>
-        </p:nvSpPr>
-        <p:spPr>
-          <a:xfrm>
-            <a:off x="6327648" y="4974336"/>
-            <a:ext cx="1188720" cy="320040"/>
-          </a:xfrm>
-          <a:prstGeom prst="rect">
-            <a:avLst/>
-          </a:prstGeom>
-          <a:noFill/>
-        </p:spPr>
-        <p:txBody>
-          <a:bodyPr wrap="square" lIns="0" rIns="0" tIns="0" bIns="0" anchor="t">
-            <a:spAutoFit/>
-          </a:bodyPr>
-          <a:lstStyle/>
-          <a:p>
-            <a:pPr algn="l">
-              <a:lnSpc>
-                <a:spcPct val="110000"/>
-              </a:lnSpc>
-            </a:pPr>
-            <a:r>
-              <a:rPr sz="1400" b="1">
-                <a:solidFill>
-                  <a:srgbClr val="1E6F63"/>
-                </a:solidFill>
-                <a:latin typeface="Segoe UI"/>
-              </a:rPr>
-              <a:t>gets</a:t>
-            </a:r>
-          </a:p>
-        </p:txBody>
-      </p:sp>
-      <p:cxnSp>
-        <p:nvCxnSpPr>
           <p:cNvPr id="82" name="Connector 81"/>
           <p:cNvCxnSpPr/>
           <p:nvPr/>
         </p:nvCxnSpPr>
         <p:spPr>
-          <a:xfrm>
-            <a:off x="7607808" y="3703320"/>
-            <a:ext cx="877824" cy="0"/>
+          <a:xfrm flipV="1">
+            <a:off x="8485632" y="2331720"/>
+            <a:ext cx="0" cy="1371600"/>
           </a:xfrm>
           <a:prstGeom prst="line">
             <a:avLst/>
@@ -12042,9 +12238,9 @@
           <p:nvPr/>
         </p:nvCxnSpPr>
         <p:spPr>
-          <a:xfrm flipV="1">
+          <a:xfrm>
             <a:off x="8485632" y="2331720"/>
-            <a:ext cx="0" cy="1371600"/>
+            <a:ext cx="548640" cy="0"/>
           </a:xfrm>
           <a:prstGeom prst="line">
             <a:avLst/>
@@ -12078,8 +12274,8 @@
         </p:nvCxnSpPr>
         <p:spPr>
           <a:xfrm>
-            <a:off x="8485632" y="2331720"/>
-            <a:ext cx="548640" cy="0"/>
+            <a:off x="7717536" y="3584448"/>
+            <a:ext cx="0" cy="237744"/>
           </a:xfrm>
           <a:prstGeom prst="line">
             <a:avLst/>
@@ -12113,7 +12309,7 @@
         </p:nvCxnSpPr>
         <p:spPr>
           <a:xfrm>
-            <a:off x="7717536" y="3584448"/>
+            <a:off x="7808976" y="3584448"/>
             <a:ext cx="0" cy="237744"/>
           </a:xfrm>
           <a:prstGeom prst="line">
@@ -12147,9 +12343,9 @@
           <p:nvPr/>
         </p:nvCxnSpPr>
         <p:spPr>
-          <a:xfrm>
-            <a:off x="7808976" y="3584448"/>
-            <a:ext cx="0" cy="237744"/>
+          <a:xfrm flipV="1">
+            <a:off x="8759952" y="2185416"/>
+            <a:ext cx="274320" cy="146304"/>
           </a:xfrm>
           <a:prstGeom prst="line">
             <a:avLst/>
@@ -12182,9 +12378,9 @@
           <p:nvPr/>
         </p:nvCxnSpPr>
         <p:spPr>
-          <a:xfrm flipV="1">
-            <a:off x="8759952" y="2185416"/>
-            <a:ext cx="274320" cy="146304"/>
+          <a:xfrm>
+            <a:off x="8759952" y="2331720"/>
+            <a:ext cx="274320" cy="0"/>
           </a:xfrm>
           <a:prstGeom prst="line">
             <a:avLst/>
@@ -12219,7 +12415,7 @@
         <p:spPr>
           <a:xfrm>
             <a:off x="8759952" y="2331720"/>
-            <a:ext cx="274320" cy="0"/>
+            <a:ext cx="274320" cy="146304"/>
           </a:xfrm>
           <a:prstGeom prst="line">
             <a:avLst/>
@@ -12253,8 +12449,8 @@
         </p:nvCxnSpPr>
         <p:spPr>
           <a:xfrm>
-            <a:off x="8759952" y="2331720"/>
-            <a:ext cx="274320" cy="146304"/>
+            <a:off x="7607808" y="4023360"/>
+            <a:ext cx="1426464" cy="0"/>
           </a:xfrm>
           <a:prstGeom prst="line">
             <a:avLst/>
@@ -12288,8 +12484,8 @@
         </p:nvCxnSpPr>
         <p:spPr>
           <a:xfrm>
-            <a:off x="7607808" y="4023360"/>
-            <a:ext cx="1426464" cy="0"/>
+            <a:off x="7717536" y="3904488"/>
+            <a:ext cx="0" cy="237744"/>
           </a:xfrm>
           <a:prstGeom prst="line">
             <a:avLst/>
@@ -12323,7 +12519,7 @@
         </p:nvCxnSpPr>
         <p:spPr>
           <a:xfrm>
-            <a:off x="7717536" y="3904488"/>
+            <a:off x="7808976" y="3904488"/>
             <a:ext cx="0" cy="237744"/>
           </a:xfrm>
           <a:prstGeom prst="line">
@@ -12358,7 +12554,7 @@
         </p:nvCxnSpPr>
         <p:spPr>
           <a:xfrm>
-            <a:off x="7808976" y="3904488"/>
+            <a:off x="8924544" y="3904488"/>
             <a:ext cx="0" cy="237744"/>
           </a:xfrm>
           <a:prstGeom prst="line">
@@ -12393,7 +12589,7 @@
         </p:nvCxnSpPr>
         <p:spPr>
           <a:xfrm>
-            <a:off x="8924544" y="3904488"/>
+            <a:off x="8833104" y="3904488"/>
             <a:ext cx="0" cy="237744"/>
           </a:xfrm>
           <a:prstGeom prst="line">
@@ -12428,8 +12624,8 @@
         </p:nvCxnSpPr>
         <p:spPr>
           <a:xfrm>
-            <a:off x="8833104" y="3904488"/>
-            <a:ext cx="0" cy="237744"/>
+            <a:off x="7607808" y="4645152"/>
+            <a:ext cx="877824" cy="0"/>
           </a:xfrm>
           <a:prstGeom prst="line">
             <a:avLst/>
@@ -12463,8 +12659,8 @@
         </p:nvCxnSpPr>
         <p:spPr>
           <a:xfrm>
-            <a:off x="7607808" y="4645152"/>
-            <a:ext cx="877824" cy="0"/>
+            <a:off x="8485632" y="4645152"/>
+            <a:ext cx="0" cy="1024128"/>
           </a:xfrm>
           <a:prstGeom prst="line">
             <a:avLst/>
@@ -12498,8 +12694,8 @@
         </p:nvCxnSpPr>
         <p:spPr>
           <a:xfrm>
-            <a:off x="8485632" y="4645152"/>
-            <a:ext cx="0" cy="1024128"/>
+            <a:off x="8485632" y="5669280"/>
+            <a:ext cx="548640" cy="0"/>
           </a:xfrm>
           <a:prstGeom prst="line">
             <a:avLst/>
@@ -12533,8 +12729,8 @@
         </p:nvCxnSpPr>
         <p:spPr>
           <a:xfrm>
-            <a:off x="8485632" y="5669280"/>
-            <a:ext cx="548640" cy="0"/>
+            <a:off x="7717536" y="4526280"/>
+            <a:ext cx="0" cy="237744"/>
           </a:xfrm>
           <a:prstGeom prst="line">
             <a:avLst/>
@@ -12568,7 +12764,7 @@
         </p:nvCxnSpPr>
         <p:spPr>
           <a:xfrm>
-            <a:off x="7717536" y="4526280"/>
+            <a:off x="7808976" y="4526280"/>
             <a:ext cx="0" cy="237744"/>
           </a:xfrm>
           <a:prstGeom prst="line">
@@ -12602,9 +12798,9 @@
           <p:nvPr/>
         </p:nvCxnSpPr>
         <p:spPr>
-          <a:xfrm>
-            <a:off x="7808976" y="4526280"/>
-            <a:ext cx="0" cy="237744"/>
+          <a:xfrm flipV="1">
+            <a:off x="8759952" y="5522976"/>
+            <a:ext cx="274320" cy="146304"/>
           </a:xfrm>
           <a:prstGeom prst="line">
             <a:avLst/>
@@ -12637,9 +12833,9 @@
           <p:nvPr/>
         </p:nvCxnSpPr>
         <p:spPr>
-          <a:xfrm flipV="1">
-            <a:off x="8759952" y="5522976"/>
-            <a:ext cx="274320" cy="146304"/>
+          <a:xfrm>
+            <a:off x="8759952" y="5669280"/>
+            <a:ext cx="274320" cy="0"/>
           </a:xfrm>
           <a:prstGeom prst="line">
             <a:avLst/>
@@ -12674,7 +12870,7 @@
         <p:spPr>
           <a:xfrm>
             <a:off x="8759952" y="5669280"/>
-            <a:ext cx="274320" cy="0"/>
+            <a:ext cx="274320" cy="146304"/>
           </a:xfrm>
           <a:prstGeom prst="line">
             <a:avLst/>
@@ -12700,44 +12896,9 @@
           </a:fontRef>
         </p:style>
       </p:cxnSp>
-      <p:cxnSp>
-        <p:nvCxnSpPr>
-          <p:cNvPr id="102" name="Connector 101"/>
-          <p:cNvCxnSpPr/>
-          <p:nvPr/>
-        </p:nvCxnSpPr>
-        <p:spPr>
-          <a:xfrm>
-            <a:off x="8759952" y="5669280"/>
-            <a:ext cx="274320" cy="146304"/>
-          </a:xfrm>
-          <a:prstGeom prst="line">
-            <a:avLst/>
-          </a:prstGeom>
-          <a:ln w="25400">
-            <a:solidFill>
-              <a:srgbClr val="0F2430"/>
-            </a:solidFill>
-          </a:ln>
-        </p:spPr>
-        <p:style>
-          <a:lnRef idx="2">
-            <a:schemeClr val="accent1"/>
-          </a:lnRef>
-          <a:fillRef idx="0">
-            <a:schemeClr val="accent1"/>
-          </a:fillRef>
-          <a:effectRef idx="1">
-            <a:schemeClr val="accent1"/>
-          </a:effectRef>
-          <a:fontRef idx="minor">
-            <a:schemeClr val="tx1"/>
-          </a:fontRef>
-        </p:style>
-      </p:cxnSp>
-      <p:sp>
-        <p:nvSpPr>
-          <p:cNvPr id="103" name="TextBox 102"/>
+      <p:sp>
+        <p:nvSpPr>
+          <p:cNvPr id="102" name="TextBox 101"/>
           <p:cNvSpPr txBox="1"/>
           <p:nvPr/>
         </p:nvSpPr>
@@ -12776,7 +12937,7 @@
       </p:sp>
       <p:sp>
         <p:nvSpPr>
-          <p:cNvPr id="104" name="TextBox 103"/>
+          <p:cNvPr id="103" name="TextBox 102"/>
           <p:cNvSpPr txBox="1"/>
           <p:nvPr/>
         </p:nvSpPr>
@@ -12952,45 +13113,6 @@
         </p:nvSpPr>
         <p:spPr>
           <a:xfrm>
-            <a:off x="640080" y="6446520"/>
-            <a:ext cx="6400800" cy="274320"/>
-          </a:xfrm>
-          <a:prstGeom prst="rect">
-            <a:avLst/>
-          </a:prstGeom>
-          <a:noFill/>
-        </p:spPr>
-        <p:txBody>
-          <a:bodyPr wrap="square" lIns="0" rIns="0" tIns="0" bIns="0" anchor="t">
-            <a:spAutoFit/>
-          </a:bodyPr>
-          <a:lstStyle/>
-          <a:p>
-            <a:pPr algn="l">
-              <a:lnSpc>
-                <a:spcPct val="110000"/>
-              </a:lnSpc>
-            </a:pPr>
-            <a:r>
-              <a:rPr sz="1200" b="0">
-                <a:solidFill>
-                  <a:srgbClr val="45555D"/>
-                </a:solidFill>
-                <a:latin typeface="Segoe UI"/>
-              </a:rPr>
-              <a:t>Sarabo  ·  Jahid Hasan  ·  Metropolitan University</a:t>
-            </a:r>
-          </a:p>
-        </p:txBody>
-      </p:sp>
-      <p:sp>
-        <p:nvSpPr>
-          <p:cNvPr id="5" name="TextBox 4"/>
-          <p:cNvSpPr txBox="1"/>
-          <p:nvPr/>
-        </p:nvSpPr>
-        <p:spPr>
-          <a:xfrm>
             <a:off x="10634472" y="6446520"/>
             <a:ext cx="914400" cy="274320"/>
           </a:xfrm>
@@ -13017,14 +13139,14 @@
                 </a:solidFill>
                 <a:latin typeface="Segoe UI"/>
               </a:rPr>
-              <a:t>6/10</a:t>
+              <a:t>6/11</a:t>
             </a:r>
           </a:p>
         </p:txBody>
       </p:sp>
       <p:pic>
         <p:nvPicPr>
-          <p:cNvPr id="6" name="Picture 5" descr="offer.png"/>
+          <p:cNvPr id="5" name="Picture 4" descr="offer.png"/>
           <p:cNvPicPr>
             <a:picLocks noChangeAspect="1"/>
           </p:cNvPicPr>
@@ -13053,7 +13175,7 @@
       </p:pic>
       <p:sp>
         <p:nvSpPr>
-          <p:cNvPr id="7" name="Rounded Rectangle 6"/>
+          <p:cNvPr id="6" name="Rounded Rectangle 5"/>
           <p:cNvSpPr/>
           <p:nvPr/>
         </p:nvSpPr>
@@ -13099,7 +13221,7 @@
       </p:sp>
       <p:sp>
         <p:nvSpPr>
-          <p:cNvPr id="8" name="TextBox 7"/>
+          <p:cNvPr id="7" name="TextBox 6"/>
           <p:cNvSpPr txBox="1"/>
           <p:nvPr/>
         </p:nvSpPr>
@@ -13197,7 +13319,7 @@
       </p:sp>
       <p:sp>
         <p:nvSpPr>
-          <p:cNvPr id="9" name="TextBox 8"/>
+          <p:cNvPr id="8" name="TextBox 7"/>
           <p:cNvSpPr txBox="1"/>
           <p:nvPr/>
         </p:nvSpPr>
@@ -13380,45 +13502,6 @@
         </p:nvSpPr>
         <p:spPr>
           <a:xfrm>
-            <a:off x="640080" y="6446520"/>
-            <a:ext cx="6400800" cy="274320"/>
-          </a:xfrm>
-          <a:prstGeom prst="rect">
-            <a:avLst/>
-          </a:prstGeom>
-          <a:noFill/>
-        </p:spPr>
-        <p:txBody>
-          <a:bodyPr wrap="square" lIns="0" rIns="0" tIns="0" bIns="0" anchor="t">
-            <a:spAutoFit/>
-          </a:bodyPr>
-          <a:lstStyle/>
-          <a:p>
-            <a:pPr algn="l">
-              <a:lnSpc>
-                <a:spcPct val="110000"/>
-              </a:lnSpc>
-            </a:pPr>
-            <a:r>
-              <a:rPr sz="1200" b="0">
-                <a:solidFill>
-                  <a:srgbClr val="45555D"/>
-                </a:solidFill>
-                <a:latin typeface="Segoe UI"/>
-              </a:rPr>
-              <a:t>Sarabo  ·  Jahid Hasan  ·  Metropolitan University</a:t>
-            </a:r>
-          </a:p>
-        </p:txBody>
-      </p:sp>
-      <p:sp>
-        <p:nvSpPr>
-          <p:cNvPr id="5" name="TextBox 4"/>
-          <p:cNvSpPr txBox="1"/>
-          <p:nvPr/>
-        </p:nvSpPr>
-        <p:spPr>
-          <a:xfrm>
             <a:off x="10634472" y="6446520"/>
             <a:ext cx="914400" cy="274320"/>
           </a:xfrm>
@@ -13445,14 +13528,14 @@
                 </a:solidFill>
                 <a:latin typeface="Segoe UI"/>
               </a:rPr>
-              <a:t>7/10</a:t>
+              <a:t>7/11</a:t>
             </a:r>
           </a:p>
         </p:txBody>
       </p:sp>
       <p:pic>
         <p:nvPicPr>
-          <p:cNvPr id="6" name="Picture 5" descr="warranty.png"/>
+          <p:cNvPr id="5" name="Picture 4" descr="warranty.png"/>
           <p:cNvPicPr>
             <a:picLocks noChangeAspect="1"/>
           </p:cNvPicPr>
@@ -13481,7 +13564,7 @@
       </p:pic>
       <p:sp>
         <p:nvSpPr>
-          <p:cNvPr id="7" name="TextBox 6"/>
+          <p:cNvPr id="6" name="TextBox 5"/>
           <p:cNvSpPr txBox="1"/>
           <p:nvPr/>
         </p:nvSpPr>
@@ -13554,7 +13637,7 @@
       </p:sp>
       <p:sp>
         <p:nvSpPr>
-          <p:cNvPr id="8" name="Rounded Rectangle 7"/>
+          <p:cNvPr id="7" name="Rounded Rectangle 6"/>
           <p:cNvSpPr/>
           <p:nvPr/>
         </p:nvSpPr>
@@ -13600,7 +13683,7 @@
       </p:sp>
       <p:sp>
         <p:nvSpPr>
-          <p:cNvPr id="9" name="TextBox 8"/>
+          <p:cNvPr id="8" name="TextBox 7"/>
           <p:cNvSpPr txBox="1"/>
           <p:nvPr/>
         </p:nvSpPr>
@@ -13639,7 +13722,7 @@
       </p:sp>
       <p:sp>
         <p:nvSpPr>
-          <p:cNvPr id="10" name="TextBox 9"/>
+          <p:cNvPr id="9" name="TextBox 8"/>
           <p:cNvSpPr txBox="1"/>
           <p:nvPr/>
         </p:nvSpPr>
@@ -13712,7 +13795,7 @@
       </p:sp>
       <p:sp>
         <p:nvSpPr>
-          <p:cNvPr id="11" name="TextBox 10"/>
+          <p:cNvPr id="10" name="TextBox 9"/>
           <p:cNvSpPr txBox="1"/>
           <p:nvPr/>
         </p:nvSpPr>
@@ -13895,45 +13978,6 @@
         </p:nvSpPr>
         <p:spPr>
           <a:xfrm>
-            <a:off x="640080" y="6446520"/>
-            <a:ext cx="6400800" cy="274320"/>
-          </a:xfrm>
-          <a:prstGeom prst="rect">
-            <a:avLst/>
-          </a:prstGeom>
-          <a:noFill/>
-        </p:spPr>
-        <p:txBody>
-          <a:bodyPr wrap="square" lIns="0" rIns="0" tIns="0" bIns="0" anchor="t">
-            <a:spAutoFit/>
-          </a:bodyPr>
-          <a:lstStyle/>
-          <a:p>
-            <a:pPr algn="l">
-              <a:lnSpc>
-                <a:spcPct val="110000"/>
-              </a:lnSpc>
-            </a:pPr>
-            <a:r>
-              <a:rPr sz="1200" b="0">
-                <a:solidFill>
-                  <a:srgbClr val="45555D"/>
-                </a:solidFill>
-                <a:latin typeface="Segoe UI"/>
-              </a:rPr>
-              <a:t>Sarabo  ·  Jahid Hasan  ·  Metropolitan University</a:t>
-            </a:r>
-          </a:p>
-        </p:txBody>
-      </p:sp>
-      <p:sp>
-        <p:nvSpPr>
-          <p:cNvPr id="5" name="TextBox 4"/>
-          <p:cNvSpPr txBox="1"/>
-          <p:nvPr/>
-        </p:nvSpPr>
-        <p:spPr>
-          <a:xfrm>
             <a:off x="10634472" y="6446520"/>
             <a:ext cx="914400" cy="274320"/>
           </a:xfrm>
@@ -13960,14 +14004,14 @@
                 </a:solidFill>
                 <a:latin typeface="Segoe UI"/>
               </a:rPr>
-              <a:t>8/10</a:t>
+              <a:t>8/11</a:t>
             </a:r>
           </a:p>
         </p:txBody>
       </p:sp>
       <p:pic>
         <p:nvPicPr>
-          <p:cNvPr id="6" name="Picture 5" descr="chat.png"/>
+          <p:cNvPr id="5" name="Picture 4" descr="chat.png"/>
           <p:cNvPicPr>
             <a:picLocks noChangeAspect="1"/>
           </p:cNvPicPr>
@@ -13996,7 +14040,7 @@
       </p:pic>
       <p:sp>
         <p:nvSpPr>
-          <p:cNvPr id="7" name="TextBox 6"/>
+          <p:cNvPr id="6" name="TextBox 5"/>
           <p:cNvSpPr txBox="1"/>
           <p:nvPr/>
         </p:nvSpPr>
@@ -14119,7 +14163,7 @@
       </p:sp>
       <p:sp>
         <p:nvSpPr>
-          <p:cNvPr id="8" name="Rounded Rectangle 7"/>
+          <p:cNvPr id="7" name="Rounded Rectangle 6"/>
           <p:cNvSpPr/>
           <p:nvPr/>
         </p:nvSpPr>
@@ -14165,7 +14209,7 @@
       </p:sp>
       <p:sp>
         <p:nvSpPr>
-          <p:cNvPr id="9" name="TextBox 8"/>
+          <p:cNvPr id="8" name="TextBox 7"/>
           <p:cNvSpPr txBox="1"/>
           <p:nvPr/>
         </p:nvSpPr>
@@ -14204,7 +14248,7 @@
       </p:sp>
       <p:sp>
         <p:nvSpPr>
-          <p:cNvPr id="10" name="TextBox 9"/>
+          <p:cNvPr id="9" name="TextBox 8"/>
           <p:cNvSpPr txBox="1"/>
           <p:nvPr/>
         </p:nvSpPr>
@@ -14437,45 +14481,6 @@
         </p:nvSpPr>
         <p:spPr>
           <a:xfrm>
-            <a:off x="640080" y="6446520"/>
-            <a:ext cx="6400800" cy="274320"/>
-          </a:xfrm>
-          <a:prstGeom prst="rect">
-            <a:avLst/>
-          </a:prstGeom>
-          <a:noFill/>
-        </p:spPr>
-        <p:txBody>
-          <a:bodyPr wrap="square" lIns="0" rIns="0" tIns="0" bIns="0" anchor="t">
-            <a:spAutoFit/>
-          </a:bodyPr>
-          <a:lstStyle/>
-          <a:p>
-            <a:pPr algn="l">
-              <a:lnSpc>
-                <a:spcPct val="110000"/>
-              </a:lnSpc>
-            </a:pPr>
-            <a:r>
-              <a:rPr sz="1200" b="0">
-                <a:solidFill>
-                  <a:srgbClr val="45555D"/>
-                </a:solidFill>
-                <a:latin typeface="Segoe UI"/>
-              </a:rPr>
-              <a:t>Sarabo  ·  Jahid Hasan  ·  Metropolitan University</a:t>
-            </a:r>
-          </a:p>
-        </p:txBody>
-      </p:sp>
-      <p:sp>
-        <p:nvSpPr>
-          <p:cNvPr id="5" name="TextBox 4"/>
-          <p:cNvSpPr txBox="1"/>
-          <p:nvPr/>
-        </p:nvSpPr>
-        <p:spPr>
-          <a:xfrm>
             <a:off x="10634472" y="6446520"/>
             <a:ext cx="914400" cy="274320"/>
           </a:xfrm>
@@ -14502,14 +14507,14 @@
                 </a:solidFill>
                 <a:latin typeface="Segoe UI"/>
               </a:rPr>
-              <a:t>9/10</a:t>
-            </a:r>
-          </a:p>
-        </p:txBody>
-      </p:sp>
-      <p:sp>
-        <p:nvSpPr>
-          <p:cNvPr id="6" name="Rounded Rectangle 5"/>
+              <a:t>9/11</a:t>
+            </a:r>
+          </a:p>
+        </p:txBody>
+      </p:sp>
+      <p:sp>
+        <p:nvSpPr>
+          <p:cNvPr id="5" name="Rounded Rectangle 4"/>
           <p:cNvSpPr/>
           <p:nvPr/>
         </p:nvSpPr>
@@ -14555,7 +14560,7 @@
       </p:sp>
       <p:sp>
         <p:nvSpPr>
-          <p:cNvPr id="7" name="TextBox 6"/>
+          <p:cNvPr id="6" name="TextBox 5"/>
           <p:cNvSpPr txBox="1"/>
           <p:nvPr/>
         </p:nvSpPr>
@@ -14594,7 +14599,7 @@
       </p:sp>
       <p:sp>
         <p:nvSpPr>
-          <p:cNvPr id="8" name="TextBox 7"/>
+          <p:cNvPr id="7" name="TextBox 6"/>
           <p:cNvSpPr txBox="1"/>
           <p:nvPr/>
         </p:nvSpPr>
@@ -14633,7 +14638,7 @@
       </p:sp>
       <p:sp>
         <p:nvSpPr>
-          <p:cNvPr id="9" name="Rounded Rectangle 8"/>
+          <p:cNvPr id="8" name="Rounded Rectangle 7"/>
           <p:cNvSpPr/>
           <p:nvPr/>
         </p:nvSpPr>
@@ -14679,7 +14684,7 @@
       </p:sp>
       <p:sp>
         <p:nvSpPr>
-          <p:cNvPr id="10" name="TextBox 9"/>
+          <p:cNvPr id="9" name="TextBox 8"/>
           <p:cNvSpPr txBox="1"/>
           <p:nvPr/>
         </p:nvSpPr>
@@ -14718,7 +14723,7 @@
       </p:sp>
       <p:sp>
         <p:nvSpPr>
-          <p:cNvPr id="11" name="TextBox 10"/>
+          <p:cNvPr id="10" name="TextBox 9"/>
           <p:cNvSpPr txBox="1"/>
           <p:nvPr/>
         </p:nvSpPr>
@@ -14757,7 +14762,7 @@
       </p:sp>
       <p:sp>
         <p:nvSpPr>
-          <p:cNvPr id="12" name="Rounded Rectangle 11"/>
+          <p:cNvPr id="11" name="Rounded Rectangle 10"/>
           <p:cNvSpPr/>
           <p:nvPr/>
         </p:nvSpPr>
@@ -14803,7 +14808,7 @@
       </p:sp>
       <p:sp>
         <p:nvSpPr>
-          <p:cNvPr id="13" name="TextBox 12"/>
+          <p:cNvPr id="12" name="TextBox 11"/>
           <p:cNvSpPr txBox="1"/>
           <p:nvPr/>
         </p:nvSpPr>
@@ -14842,7 +14847,7 @@
       </p:sp>
       <p:sp>
         <p:nvSpPr>
-          <p:cNvPr id="14" name="TextBox 13"/>
+          <p:cNvPr id="13" name="TextBox 12"/>
           <p:cNvSpPr txBox="1"/>
           <p:nvPr/>
         </p:nvSpPr>
@@ -14881,7 +14886,7 @@
       </p:sp>
       <p:cxnSp>
         <p:nvCxnSpPr>
-          <p:cNvPr id="15" name="Connector 14"/>
+          <p:cNvPr id="14" name="Connector 13"/>
           <p:cNvCxnSpPr/>
           <p:nvPr/>
         </p:nvCxnSpPr>
@@ -14917,7 +14922,7 @@
       </p:cxnSp>
       <p:cxnSp>
         <p:nvCxnSpPr>
-          <p:cNvPr id="16" name="Connector 15"/>
+          <p:cNvPr id="15" name="Connector 14"/>
           <p:cNvCxnSpPr/>
           <p:nvPr/>
         </p:nvCxnSpPr>
@@ -14953,7 +14958,7 @@
       </p:cxnSp>
       <p:sp>
         <p:nvSpPr>
-          <p:cNvPr id="17" name="TextBox 16"/>
+          <p:cNvPr id="16" name="TextBox 15"/>
           <p:cNvSpPr txBox="1"/>
           <p:nvPr/>
         </p:nvSpPr>
@@ -14992,7 +14997,7 @@
       </p:sp>
       <p:sp>
         <p:nvSpPr>
-          <p:cNvPr id="18" name="Rounded Rectangle 17"/>
+          <p:cNvPr id="17" name="Rounded Rectangle 16"/>
           <p:cNvSpPr/>
           <p:nvPr/>
         </p:nvSpPr>
@@ -15040,7 +15045,7 @@
       </p:sp>
       <p:sp>
         <p:nvSpPr>
-          <p:cNvPr id="19" name="Rectangle 18"/>
+          <p:cNvPr id="18" name="Rectangle 17"/>
           <p:cNvSpPr/>
           <p:nvPr/>
         </p:nvSpPr>
@@ -15084,7 +15089,7 @@
       </p:sp>
       <p:sp>
         <p:nvSpPr>
-          <p:cNvPr id="20" name="TextBox 19"/>
+          <p:cNvPr id="19" name="TextBox 18"/>
           <p:cNvSpPr txBox="1"/>
           <p:nvPr/>
         </p:nvSpPr>
@@ -15123,7 +15128,7 @@
       </p:sp>
       <p:sp>
         <p:nvSpPr>
-          <p:cNvPr id="21" name="TextBox 20"/>
+          <p:cNvPr id="20" name="TextBox 19"/>
           <p:cNvSpPr txBox="1"/>
           <p:nvPr/>
         </p:nvSpPr>
@@ -15162,7 +15167,7 @@
       </p:sp>
       <p:sp>
         <p:nvSpPr>
-          <p:cNvPr id="22" name="Rounded Rectangle 21"/>
+          <p:cNvPr id="21" name="Rounded Rectangle 20"/>
           <p:cNvSpPr/>
           <p:nvPr/>
         </p:nvSpPr>
@@ -15210,7 +15215,7 @@
       </p:sp>
       <p:sp>
         <p:nvSpPr>
-          <p:cNvPr id="23" name="Rectangle 22"/>
+          <p:cNvPr id="22" name="Rectangle 21"/>
           <p:cNvSpPr/>
           <p:nvPr/>
         </p:nvSpPr>
@@ -15254,7 +15259,7 @@
       </p:sp>
       <p:sp>
         <p:nvSpPr>
-          <p:cNvPr id="24" name="TextBox 23"/>
+          <p:cNvPr id="23" name="TextBox 22"/>
           <p:cNvSpPr txBox="1"/>
           <p:nvPr/>
         </p:nvSpPr>
@@ -15293,7 +15298,7 @@
       </p:sp>
       <p:sp>
         <p:nvSpPr>
-          <p:cNvPr id="25" name="TextBox 24"/>
+          <p:cNvPr id="24" name="TextBox 23"/>
           <p:cNvSpPr txBox="1"/>
           <p:nvPr/>
         </p:nvSpPr>
@@ -15332,7 +15337,7 @@
       </p:sp>
       <p:sp>
         <p:nvSpPr>
-          <p:cNvPr id="26" name="Rounded Rectangle 25"/>
+          <p:cNvPr id="25" name="Rounded Rectangle 24"/>
           <p:cNvSpPr/>
           <p:nvPr/>
         </p:nvSpPr>
@@ -15380,7 +15385,7 @@
       </p:sp>
       <p:sp>
         <p:nvSpPr>
-          <p:cNvPr id="27" name="Rectangle 26"/>
+          <p:cNvPr id="26" name="Rectangle 25"/>
           <p:cNvSpPr/>
           <p:nvPr/>
         </p:nvSpPr>
@@ -15424,7 +15429,7 @@
       </p:sp>
       <p:sp>
         <p:nvSpPr>
-          <p:cNvPr id="28" name="TextBox 27"/>
+          <p:cNvPr id="27" name="TextBox 26"/>
           <p:cNvSpPr txBox="1"/>
           <p:nvPr/>
         </p:nvSpPr>
@@ -15463,7 +15468,7 @@
       </p:sp>
       <p:sp>
         <p:nvSpPr>
-          <p:cNvPr id="29" name="TextBox 28"/>
+          <p:cNvPr id="28" name="TextBox 27"/>
           <p:cNvSpPr txBox="1"/>
           <p:nvPr/>
         </p:nvSpPr>

</xml_diff>